<commit_message>
Final Project: Code Cleanup
</commit_message>
<xml_diff>
--- a/HIGH_RISK_PROJECT/HIGH_RISK_PROJECT_SLIDES.pptx
+++ b/HIGH_RISK_PROJECT/HIGH_RISK_PROJECT_SLIDES.pptx
@@ -7,6 +7,12 @@
   <p:sldIdLst>
     <p:sldId id="256" r:id="rId2"/>
     <p:sldId id="257" r:id="rId3"/>
+    <p:sldId id="258" r:id="rId4"/>
+    <p:sldId id="265" r:id="rId5"/>
+    <p:sldId id="259" r:id="rId6"/>
+    <p:sldId id="262" r:id="rId7"/>
+    <p:sldId id="261" r:id="rId8"/>
+    <p:sldId id="264" r:id="rId9"/>
   </p:sldIdLst>
   <p:sldSz cx="12192000" cy="6858000"/>
   <p:notesSz cx="6858000" cy="9144000"/>
@@ -3880,7 +3886,7 @@
           <a:p>
             <a:r>
               <a:rPr lang="en-US" dirty="0"/>
-              <a:t>ED Fast Track Prediction</a:t>
+              <a:t>ED Fast-Track Prediction</a:t>
             </a:r>
           </a:p>
         </p:txBody>
@@ -3929,6 +3935,14 @@
 <file path=ppt/slides/slide2.xml><?xml version="1.0" encoding="utf-8"?>
 <p:sld xmlns:a="http://schemas.openxmlformats.org/drawingml/2006/main" xmlns:r="http://schemas.openxmlformats.org/officeDocument/2006/relationships" xmlns:p="http://schemas.openxmlformats.org/presentationml/2006/main">
   <p:cSld>
+    <p:bg>
+      <p:bgPr>
+        <a:solidFill>
+          <a:schemeClr val="bg1"/>
+        </a:solidFill>
+        <a:effectLst/>
+      </p:bgPr>
+    </p:bg>
     <p:spTree>
       <p:nvGrpSpPr>
         <p:cNvPr id="1" name=""/>
@@ -3943,6 +3957,263 @@
           <a:chExt cx="0" cy="0"/>
         </a:xfrm>
       </p:grpSpPr>
+      <p:sp useBgFill="1">
+        <p:nvSpPr>
+          <p:cNvPr id="1036" name="Rectangle 1035">
+            <a:extLst>
+              <a:ext uri="{FF2B5EF4-FFF2-40B4-BE49-F238E27FC236}">
+                <a16:creationId xmlns:a16="http://schemas.microsoft.com/office/drawing/2014/main" id="{1A8AF9B1-7D64-4564-969F-CB2B27ED9EC7}"/>
+              </a:ext>
+              <a:ext uri="{C183D7F6-B498-43B3-948B-1728B52AA6E4}">
+                <adec:decorative xmlns:adec="http://schemas.microsoft.com/office/drawing/2017/decorative" val="1"/>
+              </a:ext>
+            </a:extLst>
+          </p:cNvPr>
+          <p:cNvSpPr>
+            <a:spLocks noGrp="1" noRot="1" noChangeAspect="1" noMove="1" noResize="1" noEditPoints="1" noAdjustHandles="1" noChangeArrowheads="1" noChangeShapeType="1" noTextEdit="1"/>
+          </p:cNvSpPr>
+          <p:nvPr>
+            <p:extLst>
+              <p:ext uri="{386F3935-93C4-4BCD-93E2-E3B085C9AB24}">
+                <p16:designElem xmlns:p16="http://schemas.microsoft.com/office/powerpoint/2015/main" val="1"/>
+              </p:ext>
+            </p:extLst>
+          </p:nvPr>
+        </p:nvSpPr>
+        <p:spPr>
+          <a:xfrm>
+            <a:off x="0" y="0"/>
+            <a:ext cx="12192000" cy="6858000"/>
+          </a:xfrm>
+          <a:prstGeom prst="rect">
+            <a:avLst/>
+          </a:prstGeom>
+          <a:ln>
+            <a:noFill/>
+          </a:ln>
+        </p:spPr>
+        <p:style>
+          <a:lnRef idx="2">
+            <a:schemeClr val="accent1">
+              <a:shade val="50000"/>
+            </a:schemeClr>
+          </a:lnRef>
+          <a:fillRef idx="1">
+            <a:schemeClr val="accent1"/>
+          </a:fillRef>
+          <a:effectRef idx="0">
+            <a:schemeClr val="accent1"/>
+          </a:effectRef>
+          <a:fontRef idx="minor">
+            <a:schemeClr val="lt1"/>
+          </a:fontRef>
+        </p:style>
+        <p:txBody>
+          <a:bodyPr rtlCol="0" anchor="ctr"/>
+          <a:lstStyle/>
+          <a:p>
+            <a:pPr algn="ctr"/>
+            <a:endParaRPr lang="en-US"/>
+          </a:p>
+        </p:txBody>
+      </p:sp>
+      <p:pic>
+        <p:nvPicPr>
+          <p:cNvPr id="1026" name="Picture 2" descr="Surprise medical bills: The doctor is not in your insurance plan - The  Boston Globe">
+            <a:extLst>
+              <a:ext uri="{FF2B5EF4-FFF2-40B4-BE49-F238E27FC236}">
+                <a16:creationId xmlns:a16="http://schemas.microsoft.com/office/drawing/2014/main" id="{EC49CB42-E33B-745E-8311-E8CAF33CF555}"/>
+              </a:ext>
+            </a:extLst>
+          </p:cNvPr>
+          <p:cNvPicPr>
+            <a:picLocks noChangeAspect="1" noChangeArrowheads="1"/>
+          </p:cNvPicPr>
+          <p:nvPr/>
+        </p:nvPicPr>
+        <p:blipFill>
+          <a:blip r:embed="rId2">
+            <a:extLst>
+              <a:ext uri="{28A0092B-C50C-407E-A947-70E740481C1C}">
+                <a14:useLocalDpi xmlns:a14="http://schemas.microsoft.com/office/drawing/2010/main" val="0"/>
+              </a:ext>
+            </a:extLst>
+          </a:blip>
+          <a:srcRect t="18773"/>
+          <a:stretch/>
+        </p:blipFill>
+        <p:spPr bwMode="auto">
+          <a:xfrm>
+            <a:off x="20" y="10"/>
+            <a:ext cx="12191980" cy="6857990"/>
+          </a:xfrm>
+          <a:prstGeom prst="rect">
+            <a:avLst/>
+          </a:prstGeom>
+          <a:noFill/>
+          <a:extLst>
+            <a:ext uri="{909E8E84-426E-40DD-AFC4-6F175D3DCCD1}">
+              <a14:hiddenFill xmlns:a14="http://schemas.microsoft.com/office/drawing/2010/main">
+                <a:solidFill>
+                  <a:srgbClr val="FFFFFF"/>
+                </a:solidFill>
+              </a14:hiddenFill>
+            </a:ext>
+          </a:extLst>
+        </p:spPr>
+      </p:pic>
+      <p:grpSp>
+        <p:nvGrpSpPr>
+          <p:cNvPr id="1037" name="Group 1036">
+            <a:extLst>
+              <a:ext uri="{FF2B5EF4-FFF2-40B4-BE49-F238E27FC236}">
+                <a16:creationId xmlns:a16="http://schemas.microsoft.com/office/drawing/2014/main" id="{8D854759-2D3E-4B54-A780-D84D49E80FE3}"/>
+              </a:ext>
+              <a:ext uri="{C183D7F6-B498-43B3-948B-1728B52AA6E4}">
+                <adec:decorative xmlns:adec="http://schemas.microsoft.com/office/drawing/2017/decorative" val="1"/>
+              </a:ext>
+            </a:extLst>
+          </p:cNvPr>
+          <p:cNvGrpSpPr>
+            <a:grpSpLocks noGrp="1" noUngrp="1" noRot="1" noChangeAspect="1" noMove="1" noResize="1"/>
+          </p:cNvGrpSpPr>
+          <p:nvPr>
+            <p:extLst>
+              <p:ext uri="{386F3935-93C4-4BCD-93E2-E3B085C9AB24}">
+                <p16:designElem xmlns:p16="http://schemas.microsoft.com/office/powerpoint/2015/main" val="1"/>
+              </p:ext>
+            </p:extLst>
+          </p:nvPr>
+        </p:nvGrpSpPr>
+        <p:grpSpPr>
+          <a:xfrm>
+            <a:off x="438068" y="457200"/>
+            <a:ext cx="3703320" cy="5935132"/>
+            <a:chOff x="438068" y="457200"/>
+            <a:chExt cx="3703320" cy="5935132"/>
+          </a:xfrm>
+        </p:grpSpPr>
+        <p:sp>
+          <p:nvSpPr>
+            <p:cNvPr id="1034" name="Rectangle 1033">
+              <a:extLst>
+                <a:ext uri="{FF2B5EF4-FFF2-40B4-BE49-F238E27FC236}">
+                  <a16:creationId xmlns:a16="http://schemas.microsoft.com/office/drawing/2014/main" id="{459856EA-FC8A-44D1-BC3D-2B8EDD0C86E1}"/>
+                </a:ext>
+                <a:ext uri="{C183D7F6-B498-43B3-948B-1728B52AA6E4}">
+                  <adec:decorative xmlns:adec="http://schemas.microsoft.com/office/drawing/2017/decorative" val="1"/>
+                </a:ext>
+              </a:extLst>
+            </p:cNvPr>
+            <p:cNvSpPr/>
+            <p:nvPr>
+              <p:extLst>
+                <p:ext uri="{386F3935-93C4-4BCD-93E2-E3B085C9AB24}">
+                  <p16:designElem xmlns:p16="http://schemas.microsoft.com/office/powerpoint/2015/main" val="1"/>
+                </p:ext>
+              </p:extLst>
+            </p:nvPr>
+          </p:nvSpPr>
+          <p:spPr>
+            <a:xfrm>
+              <a:off x="438068" y="618067"/>
+              <a:ext cx="3702134" cy="5774265"/>
+            </a:xfrm>
+            <a:prstGeom prst="rect">
+              <a:avLst/>
+            </a:prstGeom>
+            <a:solidFill>
+              <a:schemeClr val="accent1">
+                <a:alpha val="97000"/>
+              </a:schemeClr>
+            </a:solidFill>
+            <a:ln w="6350" cmpd="sng">
+              <a:noFill/>
+            </a:ln>
+            <a:effectLst/>
+          </p:spPr>
+          <p:style>
+            <a:lnRef idx="1">
+              <a:schemeClr val="accent1"/>
+            </a:lnRef>
+            <a:fillRef idx="3">
+              <a:schemeClr val="accent1"/>
+            </a:fillRef>
+            <a:effectRef idx="2">
+              <a:schemeClr val="accent1"/>
+            </a:effectRef>
+            <a:fontRef idx="minor">
+              <a:schemeClr val="lt1"/>
+            </a:fontRef>
+          </p:style>
+          <p:txBody>
+            <a:bodyPr/>
+            <a:lstStyle/>
+            <a:p>
+              <a:endParaRPr lang="en-US"/>
+            </a:p>
+          </p:txBody>
+        </p:sp>
+        <p:sp>
+          <p:nvSpPr>
+            <p:cNvPr id="1035" name="Rectangle 1034">
+              <a:extLst>
+                <a:ext uri="{FF2B5EF4-FFF2-40B4-BE49-F238E27FC236}">
+                  <a16:creationId xmlns:a16="http://schemas.microsoft.com/office/drawing/2014/main" id="{C1038B56-933B-44DD-AF10-63436FCCFBC1}"/>
+                </a:ext>
+                <a:ext uri="{C183D7F6-B498-43B3-948B-1728B52AA6E4}">
+                  <adec:decorative xmlns:adec="http://schemas.microsoft.com/office/drawing/2017/decorative" val="1"/>
+                </a:ext>
+              </a:extLst>
+            </p:cNvPr>
+            <p:cNvSpPr/>
+            <p:nvPr>
+              <p:extLst>
+                <p:ext uri="{386F3935-93C4-4BCD-93E2-E3B085C9AB24}">
+                  <p16:designElem xmlns:p16="http://schemas.microsoft.com/office/powerpoint/2015/main" val="1"/>
+                </p:ext>
+              </p:extLst>
+            </p:nvPr>
+          </p:nvSpPr>
+          <p:spPr>
+            <a:xfrm>
+              <a:off x="438068" y="457200"/>
+              <a:ext cx="3703320" cy="94997"/>
+            </a:xfrm>
+            <a:prstGeom prst="rect">
+              <a:avLst/>
+            </a:prstGeom>
+            <a:solidFill>
+              <a:schemeClr val="accent1"/>
+            </a:solidFill>
+            <a:ln>
+              <a:noFill/>
+            </a:ln>
+            <a:effectLst/>
+          </p:spPr>
+          <p:style>
+            <a:lnRef idx="1">
+              <a:schemeClr val="accent1"/>
+            </a:lnRef>
+            <a:fillRef idx="3">
+              <a:schemeClr val="accent1"/>
+            </a:fillRef>
+            <a:effectRef idx="2">
+              <a:schemeClr val="accent1"/>
+            </a:effectRef>
+            <a:fontRef idx="minor">
+              <a:schemeClr val="lt1"/>
+            </a:fontRef>
+          </p:style>
+          <p:txBody>
+            <a:bodyPr/>
+            <a:lstStyle/>
+            <a:p>
+              <a:endParaRPr lang="en-US"/>
+            </a:p>
+          </p:txBody>
+        </p:sp>
+      </p:grpSp>
       <p:sp>
         <p:nvSpPr>
           <p:cNvPr id="2" name="Title 1">
@@ -3959,12 +4230,26 @@
             <p:ph type="title"/>
           </p:nvPr>
         </p:nvSpPr>
-        <p:spPr/>
-        <p:txBody>
-          <a:bodyPr/>
+        <p:spPr>
+          <a:xfrm>
+            <a:off x="584200" y="1006956"/>
+            <a:ext cx="3412067" cy="1372177"/>
+          </a:xfrm>
+        </p:spPr>
+        <p:txBody>
+          <a:bodyPr anchor="ctr">
+            <a:normAutofit/>
+          </a:bodyPr>
           <a:lstStyle/>
           <a:p>
-            <a:endParaRPr lang="en-US"/>
+            <a:r>
+              <a:rPr lang="en-US" dirty="0">
+                <a:solidFill>
+                  <a:srgbClr val="FFFFFF"/>
+                </a:solidFill>
+              </a:rPr>
+              <a:t>Hospital Emergency Department (ED)</a:t>
+            </a:r>
           </a:p>
         </p:txBody>
       </p:sp>
@@ -3984,12 +4269,70 @@
             <p:ph idx="1"/>
           </p:nvPr>
         </p:nvSpPr>
-        <p:spPr/>
-        <p:txBody>
-          <a:bodyPr/>
+        <p:spPr>
+          <a:xfrm>
+            <a:off x="581193" y="2438399"/>
+            <a:ext cx="3415074" cy="3564467"/>
+          </a:xfrm>
+        </p:spPr>
+        <p:txBody>
+          <a:bodyPr>
+            <a:normAutofit/>
+          </a:bodyPr>
           <a:lstStyle/>
           <a:p>
-            <a:endParaRPr lang="en-US"/>
+            <a:r>
+              <a:rPr lang="en-US" dirty="0">
+                <a:solidFill>
+                  <a:srgbClr val="FFFFFF"/>
+                </a:solidFill>
+              </a:rPr>
+              <a:t>Patients can arrive without appointments for 24/7 care</a:t>
+            </a:r>
+            <a:br>
+              <a:rPr lang="en-US" dirty="0">
+                <a:solidFill>
+                  <a:srgbClr val="FFFFFF"/>
+                </a:solidFill>
+              </a:rPr>
+            </a:br>
+            <a:endParaRPr lang="en-US" dirty="0">
+              <a:solidFill>
+                <a:srgbClr val="FFFFFF"/>
+              </a:solidFill>
+            </a:endParaRPr>
+          </a:p>
+          <a:p>
+            <a:r>
+              <a:rPr lang="en-US" dirty="0">
+                <a:solidFill>
+                  <a:srgbClr val="FFFFFF"/>
+                </a:solidFill>
+              </a:rPr>
+              <a:t>Conditions can range from non-urgent to critical</a:t>
+            </a:r>
+            <a:br>
+              <a:rPr lang="en-US" dirty="0">
+                <a:solidFill>
+                  <a:srgbClr val="FFFFFF"/>
+                </a:solidFill>
+              </a:rPr>
+            </a:br>
+            <a:endParaRPr lang="en-US" dirty="0">
+              <a:solidFill>
+                <a:srgbClr val="FFFFFF"/>
+              </a:solidFill>
+            </a:endParaRPr>
+          </a:p>
+          <a:p>
+            <a:r>
+              <a:rPr lang="en-US" dirty="0">
+                <a:solidFill>
+                  <a:srgbClr val="FFFFFF"/>
+                </a:solidFill>
+              </a:rPr>
+              <a:t>Wait times depend on factors like occupancy, staff, and resources available</a:t>
+            </a:r>
           </a:p>
         </p:txBody>
       </p:sp>
@@ -4001,7 +4344,2098 @@
     </p:extLst>
   </p:cSld>
   <p:clrMapOvr>
+    <a:overrideClrMapping bg1="dk1" tx1="lt1" bg2="dk2" tx2="lt2" accent1="accent1" accent2="accent2" accent3="accent3" accent4="accent4" accent5="accent5" accent6="accent6" hlink="hlink" folHlink="folHlink"/>
+  </p:clrMapOvr>
+</p:sld>
+</file>
+
+<file path=ppt/slides/slide3.xml><?xml version="1.0" encoding="utf-8"?>
+<p:sld xmlns:a="http://schemas.openxmlformats.org/drawingml/2006/main" xmlns:r="http://schemas.openxmlformats.org/officeDocument/2006/relationships" xmlns:p="http://schemas.openxmlformats.org/presentationml/2006/main">
+  <p:cSld>
+    <p:bg>
+      <p:bgPr>
+        <a:solidFill>
+          <a:schemeClr val="bg1"/>
+        </a:solidFill>
+        <a:effectLst/>
+      </p:bgPr>
+    </p:bg>
+    <p:spTree>
+      <p:nvGrpSpPr>
+        <p:cNvPr id="1" name=""/>
+        <p:cNvGrpSpPr/>
+        <p:nvPr/>
+      </p:nvGrpSpPr>
+      <p:grpSpPr>
+        <a:xfrm>
+          <a:off x="0" y="0"/>
+          <a:ext cx="0" cy="0"/>
+          <a:chOff x="0" y="0"/>
+          <a:chExt cx="0" cy="0"/>
+        </a:xfrm>
+      </p:grpSpPr>
+      <p:sp>
+        <p:nvSpPr>
+          <p:cNvPr id="2059" name="Rectangle 2058">
+            <a:extLst>
+              <a:ext uri="{FF2B5EF4-FFF2-40B4-BE49-F238E27FC236}">
+                <a16:creationId xmlns:a16="http://schemas.microsoft.com/office/drawing/2014/main" id="{1E5E4503-CC62-4DA9-9121-0A15719984CE}"/>
+              </a:ext>
+              <a:ext uri="{C183D7F6-B498-43B3-948B-1728B52AA6E4}">
+                <adec:decorative xmlns:adec="http://schemas.microsoft.com/office/drawing/2017/decorative" val="1"/>
+              </a:ext>
+            </a:extLst>
+          </p:cNvPr>
+          <p:cNvSpPr>
+            <a:spLocks noGrp="1" noRot="1" noChangeAspect="1" noMove="1" noResize="1" noEditPoints="1" noAdjustHandles="1" noChangeArrowheads="1" noChangeShapeType="1" noTextEdit="1"/>
+          </p:cNvSpPr>
+          <p:nvPr>
+            <p:extLst>
+              <p:ext uri="{386F3935-93C4-4BCD-93E2-E3B085C9AB24}">
+                <p16:designElem xmlns:p16="http://schemas.microsoft.com/office/powerpoint/2015/main" val="1"/>
+              </p:ext>
+            </p:extLst>
+          </p:nvPr>
+        </p:nvSpPr>
+        <p:spPr>
+          <a:xfrm>
+            <a:off x="446534" y="457200"/>
+            <a:ext cx="3703320" cy="94997"/>
+          </a:xfrm>
+          <a:prstGeom prst="rect">
+            <a:avLst/>
+          </a:prstGeom>
+          <a:solidFill>
+            <a:schemeClr val="accent1"/>
+          </a:solidFill>
+          <a:ln>
+            <a:noFill/>
+          </a:ln>
+          <a:effectLst/>
+        </p:spPr>
+        <p:style>
+          <a:lnRef idx="1">
+            <a:schemeClr val="accent1"/>
+          </a:lnRef>
+          <a:fillRef idx="3">
+            <a:schemeClr val="accent1"/>
+          </a:fillRef>
+          <a:effectRef idx="2">
+            <a:schemeClr val="accent1"/>
+          </a:effectRef>
+          <a:fontRef idx="minor">
+            <a:schemeClr val="lt1"/>
+          </a:fontRef>
+        </p:style>
+        <p:txBody>
+          <a:bodyPr/>
+          <a:lstStyle/>
+          <a:p>
+            <a:endParaRPr lang="en-US"/>
+          </a:p>
+        </p:txBody>
+      </p:sp>
+      <p:sp>
+        <p:nvSpPr>
+          <p:cNvPr id="2061" name="Rectangle 2060">
+            <a:extLst>
+              <a:ext uri="{FF2B5EF4-FFF2-40B4-BE49-F238E27FC236}">
+                <a16:creationId xmlns:a16="http://schemas.microsoft.com/office/drawing/2014/main" id="{D8D61A1B-3C4C-4F0E-965F-15837624CF5B}"/>
+              </a:ext>
+              <a:ext uri="{C183D7F6-B498-43B3-948B-1728B52AA6E4}">
+                <adec:decorative xmlns:adec="http://schemas.microsoft.com/office/drawing/2017/decorative" val="1"/>
+              </a:ext>
+            </a:extLst>
+          </p:cNvPr>
+          <p:cNvSpPr>
+            <a:spLocks noGrp="1" noRot="1" noChangeAspect="1" noMove="1" noResize="1" noEditPoints="1" noAdjustHandles="1" noChangeArrowheads="1" noChangeShapeType="1" noTextEdit="1"/>
+          </p:cNvSpPr>
+          <p:nvPr>
+            <p:extLst>
+              <p:ext uri="{386F3935-93C4-4BCD-93E2-E3B085C9AB24}">
+                <p16:designElem xmlns:p16="http://schemas.microsoft.com/office/powerpoint/2015/main" val="1"/>
+              </p:ext>
+            </p:extLst>
+          </p:nvPr>
+        </p:nvSpPr>
+        <p:spPr>
+          <a:xfrm>
+            <a:off x="8042147" y="453643"/>
+            <a:ext cx="3703320" cy="98554"/>
+          </a:xfrm>
+          <a:prstGeom prst="rect">
+            <a:avLst/>
+          </a:prstGeom>
+          <a:solidFill>
+            <a:schemeClr val="accent4"/>
+          </a:solidFill>
+          <a:ln>
+            <a:noFill/>
+          </a:ln>
+          <a:effectLst/>
+        </p:spPr>
+        <p:style>
+          <a:lnRef idx="1">
+            <a:schemeClr val="accent1"/>
+          </a:lnRef>
+          <a:fillRef idx="3">
+            <a:schemeClr val="accent1"/>
+          </a:fillRef>
+          <a:effectRef idx="2">
+            <a:schemeClr val="accent1"/>
+          </a:effectRef>
+          <a:fontRef idx="minor">
+            <a:schemeClr val="lt1"/>
+          </a:fontRef>
+        </p:style>
+        <p:txBody>
+          <a:bodyPr/>
+          <a:lstStyle/>
+          <a:p>
+            <a:endParaRPr lang="en-US"/>
+          </a:p>
+        </p:txBody>
+      </p:sp>
+      <p:sp>
+        <p:nvSpPr>
+          <p:cNvPr id="2063" name="Rectangle 2062">
+            <a:extLst>
+              <a:ext uri="{FF2B5EF4-FFF2-40B4-BE49-F238E27FC236}">
+                <a16:creationId xmlns:a16="http://schemas.microsoft.com/office/drawing/2014/main" id="{00E56243-9701-44E8-8A92-319433305195}"/>
+              </a:ext>
+              <a:ext uri="{C183D7F6-B498-43B3-948B-1728B52AA6E4}">
+                <adec:decorative xmlns:adec="http://schemas.microsoft.com/office/drawing/2017/decorative" val="1"/>
+              </a:ext>
+            </a:extLst>
+          </p:cNvPr>
+          <p:cNvSpPr>
+            <a:spLocks noGrp="1" noRot="1" noChangeAspect="1" noMove="1" noResize="1" noEditPoints="1" noAdjustHandles="1" noChangeArrowheads="1" noChangeShapeType="1" noTextEdit="1"/>
+          </p:cNvSpPr>
+          <p:nvPr>
+            <p:extLst>
+              <p:ext uri="{386F3935-93C4-4BCD-93E2-E3B085C9AB24}">
+                <p16:designElem xmlns:p16="http://schemas.microsoft.com/office/powerpoint/2015/main" val="1"/>
+              </p:ext>
+            </p:extLst>
+          </p:nvPr>
+        </p:nvSpPr>
+        <p:spPr>
+          <a:xfrm>
+            <a:off x="4241830" y="457200"/>
+            <a:ext cx="3703320" cy="91440"/>
+          </a:xfrm>
+          <a:prstGeom prst="rect">
+            <a:avLst/>
+          </a:prstGeom>
+          <a:solidFill>
+            <a:schemeClr val="accent2"/>
+          </a:solidFill>
+          <a:ln>
+            <a:noFill/>
+          </a:ln>
+          <a:effectLst/>
+        </p:spPr>
+        <p:style>
+          <a:lnRef idx="1">
+            <a:schemeClr val="accent1"/>
+          </a:lnRef>
+          <a:fillRef idx="3">
+            <a:schemeClr val="accent1"/>
+          </a:fillRef>
+          <a:effectRef idx="2">
+            <a:schemeClr val="accent1"/>
+          </a:effectRef>
+          <a:fontRef idx="minor">
+            <a:schemeClr val="lt1"/>
+          </a:fontRef>
+        </p:style>
+        <p:txBody>
+          <a:bodyPr/>
+          <a:lstStyle/>
+          <a:p>
+            <a:endParaRPr lang="en-US"/>
+          </a:p>
+        </p:txBody>
+      </p:sp>
+      <p:sp>
+        <p:nvSpPr>
+          <p:cNvPr id="2065" name="Rectangle 2064">
+            <a:extLst>
+              <a:ext uri="{FF2B5EF4-FFF2-40B4-BE49-F238E27FC236}">
+                <a16:creationId xmlns:a16="http://schemas.microsoft.com/office/drawing/2014/main" id="{5B1F1915-E076-48EB-BB4A-EE9808EB40CB}"/>
+              </a:ext>
+              <a:ext uri="{C183D7F6-B498-43B3-948B-1728B52AA6E4}">
+                <adec:decorative xmlns:adec="http://schemas.microsoft.com/office/drawing/2017/decorative" val="1"/>
+              </a:ext>
+            </a:extLst>
+          </p:cNvPr>
+          <p:cNvSpPr>
+            <a:spLocks noGrp="1" noRot="1" noChangeAspect="1" noMove="1" noResize="1" noEditPoints="1" noAdjustHandles="1" noChangeArrowheads="1" noChangeShapeType="1" noTextEdit="1"/>
+          </p:cNvSpPr>
+          <p:nvPr>
+            <p:extLst>
+              <p:ext uri="{386F3935-93C4-4BCD-93E2-E3B085C9AB24}">
+                <p16:designElem xmlns:p16="http://schemas.microsoft.com/office/powerpoint/2015/main" val="1"/>
+              </p:ext>
+            </p:extLst>
+          </p:nvPr>
+        </p:nvSpPr>
+        <p:spPr>
+          <a:xfrm>
+            <a:off x="446534" y="3085765"/>
+            <a:ext cx="11262866" cy="3304800"/>
+          </a:xfrm>
+          <a:prstGeom prst="rect">
+            <a:avLst/>
+          </a:prstGeom>
+          <a:solidFill>
+            <a:schemeClr val="accent1"/>
+          </a:solidFill>
+          <a:ln>
+            <a:noFill/>
+          </a:ln>
+          <a:effectLst/>
+        </p:spPr>
+        <p:style>
+          <a:lnRef idx="1">
+            <a:schemeClr val="accent1"/>
+          </a:lnRef>
+          <a:fillRef idx="3">
+            <a:schemeClr val="accent1"/>
+          </a:fillRef>
+          <a:effectRef idx="2">
+            <a:schemeClr val="accent1"/>
+          </a:effectRef>
+          <a:fontRef idx="minor">
+            <a:schemeClr val="lt1"/>
+          </a:fontRef>
+        </p:style>
+        <p:txBody>
+          <a:bodyPr/>
+          <a:lstStyle/>
+          <a:p>
+            <a:endParaRPr lang="en-US"/>
+          </a:p>
+        </p:txBody>
+      </p:sp>
+      <p:sp>
+        <p:nvSpPr>
+          <p:cNvPr id="2067" name="Rectangle 2066">
+            <a:extLst>
+              <a:ext uri="{FF2B5EF4-FFF2-40B4-BE49-F238E27FC236}">
+                <a16:creationId xmlns:a16="http://schemas.microsoft.com/office/drawing/2014/main" id="{CB2C2501-B64D-4866-AF9F-64F65F7CC59D}"/>
+              </a:ext>
+              <a:ext uri="{C183D7F6-B498-43B3-948B-1728B52AA6E4}">
+                <adec:decorative xmlns:adec="http://schemas.microsoft.com/office/drawing/2017/decorative" val="1"/>
+              </a:ext>
+            </a:extLst>
+          </p:cNvPr>
+          <p:cNvSpPr>
+            <a:spLocks noGrp="1" noRot="1" noChangeAspect="1" noMove="1" noResize="1" noEditPoints="1" noAdjustHandles="1" noChangeArrowheads="1" noChangeShapeType="1" noTextEdit="1"/>
+          </p:cNvSpPr>
+          <p:nvPr>
+            <p:extLst>
+              <p:ext uri="{386F3935-93C4-4BCD-93E2-E3B085C9AB24}">
+                <p16:designElem xmlns:p16="http://schemas.microsoft.com/office/powerpoint/2015/main" val="1"/>
+              </p:ext>
+            </p:extLst>
+          </p:nvPr>
+        </p:nvSpPr>
+        <p:spPr>
+          <a:xfrm>
+            <a:off x="0" y="-460"/>
+            <a:ext cx="12192000" cy="6858000"/>
+          </a:xfrm>
+          <a:prstGeom prst="rect">
+            <a:avLst/>
+          </a:prstGeom>
+          <a:solidFill>
+            <a:schemeClr val="bg1"/>
+          </a:solidFill>
+          <a:ln>
+            <a:noFill/>
+          </a:ln>
+          <a:effectLst/>
+        </p:spPr>
+        <p:style>
+          <a:lnRef idx="1">
+            <a:schemeClr val="accent1"/>
+          </a:lnRef>
+          <a:fillRef idx="3">
+            <a:schemeClr val="accent1"/>
+          </a:fillRef>
+          <a:effectRef idx="2">
+            <a:schemeClr val="accent1"/>
+          </a:effectRef>
+          <a:fontRef idx="minor">
+            <a:schemeClr val="lt1"/>
+          </a:fontRef>
+        </p:style>
+        <p:txBody>
+          <a:bodyPr rtlCol="0" anchor="ctr"/>
+          <a:lstStyle/>
+          <a:p>
+            <a:pPr algn="ctr"/>
+            <a:endParaRPr lang="en-US"/>
+          </a:p>
+        </p:txBody>
+      </p:sp>
+      <p:pic>
+        <p:nvPicPr>
+          <p:cNvPr id="2052" name="Picture 4" descr="South Florida medical center opens fast track emergency room">
+            <a:extLst>
+              <a:ext uri="{FF2B5EF4-FFF2-40B4-BE49-F238E27FC236}">
+                <a16:creationId xmlns:a16="http://schemas.microsoft.com/office/drawing/2014/main" id="{7A023D93-94A6-B095-028D-441133E628E1}"/>
+              </a:ext>
+            </a:extLst>
+          </p:cNvPr>
+          <p:cNvPicPr>
+            <a:picLocks noChangeAspect="1" noChangeArrowheads="1"/>
+          </p:cNvPicPr>
+          <p:nvPr/>
+        </p:nvPicPr>
+        <p:blipFill>
+          <a:blip r:embed="rId2">
+            <a:extLst>
+              <a:ext uri="{28A0092B-C50C-407E-A947-70E740481C1C}">
+                <a14:useLocalDpi xmlns:a14="http://schemas.microsoft.com/office/drawing/2010/main" val="0"/>
+              </a:ext>
+            </a:extLst>
+          </a:blip>
+          <a:srcRect l="27783" r="11468" b="1"/>
+          <a:stretch/>
+        </p:blipFill>
+        <p:spPr bwMode="auto">
+          <a:xfrm>
+            <a:off x="20" y="10"/>
+            <a:ext cx="4544548" cy="4219688"/>
+          </a:xfrm>
+          <a:prstGeom prst="rect">
+            <a:avLst/>
+          </a:prstGeom>
+          <a:noFill/>
+          <a:extLst>
+            <a:ext uri="{909E8E84-426E-40DD-AFC4-6F175D3DCCD1}">
+              <a14:hiddenFill xmlns:a14="http://schemas.microsoft.com/office/drawing/2010/main">
+                <a:solidFill>
+                  <a:srgbClr val="FFFFFF"/>
+                </a:solidFill>
+              </a14:hiddenFill>
+            </a:ext>
+          </a:extLst>
+        </p:spPr>
+      </p:pic>
+      <p:pic>
+        <p:nvPicPr>
+          <p:cNvPr id="2054" name="Picture 6" descr="New 'Fast Track' Emergency Service Opens in Bullitt County | Louisville KY  | UofL Health">
+            <a:extLst>
+              <a:ext uri="{FF2B5EF4-FFF2-40B4-BE49-F238E27FC236}">
+                <a16:creationId xmlns:a16="http://schemas.microsoft.com/office/drawing/2014/main" id="{D2032887-470B-A355-B0D2-79250453A318}"/>
+              </a:ext>
+            </a:extLst>
+          </p:cNvPr>
+          <p:cNvPicPr>
+            <a:picLocks noChangeAspect="1" noChangeArrowheads="1"/>
+          </p:cNvPicPr>
+          <p:nvPr/>
+        </p:nvPicPr>
+        <p:blipFill>
+          <a:blip r:embed="rId3">
+            <a:extLst>
+              <a:ext uri="{28A0092B-C50C-407E-A947-70E740481C1C}">
+                <a14:useLocalDpi xmlns:a14="http://schemas.microsoft.com/office/drawing/2010/main" val="0"/>
+              </a:ext>
+            </a:extLst>
+          </a:blip>
+          <a:srcRect l="14994" r="5688" b="1"/>
+          <a:stretch/>
+        </p:blipFill>
+        <p:spPr bwMode="auto">
+          <a:xfrm>
+            <a:off x="4628829" y="10"/>
+            <a:ext cx="7563171" cy="4266944"/>
+          </a:xfrm>
+          <a:prstGeom prst="rect">
+            <a:avLst/>
+          </a:prstGeom>
+          <a:noFill/>
+          <a:extLst>
+            <a:ext uri="{909E8E84-426E-40DD-AFC4-6F175D3DCCD1}">
+              <a14:hiddenFill xmlns:a14="http://schemas.microsoft.com/office/drawing/2010/main">
+                <a:solidFill>
+                  <a:srgbClr val="FFFFFF"/>
+                </a:solidFill>
+              </a14:hiddenFill>
+            </a:ext>
+          </a:extLst>
+        </p:spPr>
+      </p:pic>
+      <p:pic>
+        <p:nvPicPr>
+          <p:cNvPr id="2050" name="Picture 2" descr="Long Beach Medical's New Fast Track Unit Will See You Now | MemorialCare">
+            <a:extLst>
+              <a:ext uri="{FF2B5EF4-FFF2-40B4-BE49-F238E27FC236}">
+                <a16:creationId xmlns:a16="http://schemas.microsoft.com/office/drawing/2014/main" id="{E093CAEB-BF97-965C-70DC-E5674D57FC1D}"/>
+              </a:ext>
+            </a:extLst>
+          </p:cNvPr>
+          <p:cNvPicPr>
+            <a:picLocks noGrp="1" noChangeAspect="1" noChangeArrowheads="1"/>
+          </p:cNvPicPr>
+          <p:nvPr>
+            <p:ph idx="1"/>
+          </p:nvPr>
+        </p:nvPicPr>
+        <p:blipFill>
+          <a:blip r:embed="rId4">
+            <a:extLst>
+              <a:ext uri="{28A0092B-C50C-407E-A947-70E740481C1C}">
+                <a14:useLocalDpi xmlns:a14="http://schemas.microsoft.com/office/drawing/2010/main" val="0"/>
+              </a:ext>
+            </a:extLst>
+          </a:blip>
+          <a:srcRect t="353" r="-3" b="-3"/>
+          <a:stretch/>
+        </p:blipFill>
+        <p:spPr bwMode="auto">
+          <a:xfrm>
+            <a:off x="20" y="4310260"/>
+            <a:ext cx="4544548" cy="2547280"/>
+          </a:xfrm>
+          <a:prstGeom prst="rect">
+            <a:avLst/>
+          </a:prstGeom>
+          <a:noFill/>
+          <a:extLst>
+            <a:ext uri="{909E8E84-426E-40DD-AFC4-6F175D3DCCD1}">
+              <a14:hiddenFill xmlns:a14="http://schemas.microsoft.com/office/drawing/2010/main">
+                <a:solidFill>
+                  <a:srgbClr val="FFFFFF"/>
+                </a:solidFill>
+              </a14:hiddenFill>
+            </a:ext>
+          </a:extLst>
+        </p:spPr>
+      </p:pic>
+      <p:sp>
+        <p:nvSpPr>
+          <p:cNvPr id="2069" name="Rectangle 2068">
+            <a:extLst>
+              <a:ext uri="{FF2B5EF4-FFF2-40B4-BE49-F238E27FC236}">
+                <a16:creationId xmlns:a16="http://schemas.microsoft.com/office/drawing/2014/main" id="{B496DDB9-0BC9-40CD-B3AE-B57DC71D7431}"/>
+              </a:ext>
+              <a:ext uri="{C183D7F6-B498-43B3-948B-1728B52AA6E4}">
+                <adec:decorative xmlns:adec="http://schemas.microsoft.com/office/drawing/2017/decorative" val="1"/>
+              </a:ext>
+            </a:extLst>
+          </p:cNvPr>
+          <p:cNvSpPr>
+            <a:spLocks noGrp="1" noRot="1" noChangeAspect="1" noMove="1" noResize="1" noEditPoints="1" noAdjustHandles="1" noChangeArrowheads="1" noChangeShapeType="1" noTextEdit="1"/>
+          </p:cNvSpPr>
+          <p:nvPr>
+            <p:extLst>
+              <p:ext uri="{386F3935-93C4-4BCD-93E2-E3B085C9AB24}">
+                <p16:designElem xmlns:p16="http://schemas.microsoft.com/office/powerpoint/2015/main" val="1"/>
+              </p:ext>
+            </p:extLst>
+          </p:nvPr>
+        </p:nvSpPr>
+        <p:spPr>
+          <a:xfrm>
+            <a:off x="4639498" y="4267831"/>
+            <a:ext cx="7552502" cy="2590169"/>
+          </a:xfrm>
+          <a:prstGeom prst="rect">
+            <a:avLst/>
+          </a:prstGeom>
+          <a:solidFill>
+            <a:schemeClr val="accent1"/>
+          </a:solidFill>
+          <a:ln w="6350" cmpd="sng">
+            <a:noFill/>
+          </a:ln>
+          <a:effectLst/>
+        </p:spPr>
+        <p:style>
+          <a:lnRef idx="1">
+            <a:schemeClr val="accent1"/>
+          </a:lnRef>
+          <a:fillRef idx="3">
+            <a:schemeClr val="accent1"/>
+          </a:fillRef>
+          <a:effectRef idx="2">
+            <a:schemeClr val="accent1"/>
+          </a:effectRef>
+          <a:fontRef idx="minor">
+            <a:schemeClr val="lt1"/>
+          </a:fontRef>
+        </p:style>
+        <p:txBody>
+          <a:bodyPr/>
+          <a:lstStyle/>
+          <a:p>
+            <a:endParaRPr lang="en-US"/>
+          </a:p>
+        </p:txBody>
+      </p:sp>
+      <p:sp>
+        <p:nvSpPr>
+          <p:cNvPr id="2" name="Title 1">
+            <a:extLst>
+              <a:ext uri="{FF2B5EF4-FFF2-40B4-BE49-F238E27FC236}">
+                <a16:creationId xmlns:a16="http://schemas.microsoft.com/office/drawing/2014/main" id="{F9BBBB69-C904-6412-F6AA-989334D891F9}"/>
+              </a:ext>
+            </a:extLst>
+          </p:cNvPr>
+          <p:cNvSpPr>
+            <a:spLocks noGrp="1"/>
+          </p:cNvSpPr>
+          <p:nvPr>
+            <p:ph type="title"/>
+          </p:nvPr>
+        </p:nvSpPr>
+        <p:spPr>
+          <a:xfrm>
+            <a:off x="4678740" y="4343986"/>
+            <a:ext cx="6025836" cy="695822"/>
+          </a:xfrm>
+        </p:spPr>
+        <p:txBody>
+          <a:bodyPr vert="horz" lIns="91440" tIns="45720" rIns="91440" bIns="45720" rtlCol="0" anchor="t">
+            <a:normAutofit/>
+          </a:bodyPr>
+          <a:lstStyle/>
+          <a:p>
+            <a:r>
+              <a:rPr lang="en-US" sz="3600" dirty="0">
+                <a:solidFill>
+                  <a:srgbClr val="FFFFFF"/>
+                </a:solidFill>
+              </a:rPr>
+              <a:t>Fast-Track  Area (FT)</a:t>
+            </a:r>
+          </a:p>
+        </p:txBody>
+      </p:sp>
+      <p:sp>
+        <p:nvSpPr>
+          <p:cNvPr id="2071" name="Rectangle 2070">
+            <a:extLst>
+              <a:ext uri="{FF2B5EF4-FFF2-40B4-BE49-F238E27FC236}">
+                <a16:creationId xmlns:a16="http://schemas.microsoft.com/office/drawing/2014/main" id="{03F4845B-54A6-46F4-B0A0-95B580A9F91B}"/>
+              </a:ext>
+              <a:ext uri="{C183D7F6-B498-43B3-948B-1728B52AA6E4}">
+                <adec:decorative xmlns:adec="http://schemas.microsoft.com/office/drawing/2017/decorative" val="1"/>
+              </a:ext>
+            </a:extLst>
+          </p:cNvPr>
+          <p:cNvSpPr>
+            <a:spLocks noGrp="1" noRot="1" noChangeAspect="1" noMove="1" noResize="1" noEditPoints="1" noAdjustHandles="1" noChangeArrowheads="1" noChangeShapeType="1" noTextEdit="1"/>
+          </p:cNvSpPr>
+          <p:nvPr>
+            <p:extLst>
+              <p:ext uri="{386F3935-93C4-4BCD-93E2-E3B085C9AB24}">
+                <p16:designElem xmlns:p16="http://schemas.microsoft.com/office/powerpoint/2015/main" val="1"/>
+              </p:ext>
+            </p:extLst>
+          </p:nvPr>
+        </p:nvSpPr>
+        <p:spPr>
+          <a:xfrm>
+            <a:off x="4505326" y="4220158"/>
+            <a:ext cx="7689094" cy="90102"/>
+          </a:xfrm>
+          <a:prstGeom prst="rect">
+            <a:avLst/>
+          </a:prstGeom>
+          <a:solidFill>
+            <a:schemeClr val="bg1"/>
+          </a:solidFill>
+          <a:ln>
+            <a:noFill/>
+          </a:ln>
+          <a:effectLst/>
+        </p:spPr>
+        <p:style>
+          <a:lnRef idx="1">
+            <a:schemeClr val="accent1"/>
+          </a:lnRef>
+          <a:fillRef idx="3">
+            <a:schemeClr val="accent1"/>
+          </a:fillRef>
+          <a:effectRef idx="2">
+            <a:schemeClr val="accent1"/>
+          </a:effectRef>
+          <a:fontRef idx="minor">
+            <a:schemeClr val="lt1"/>
+          </a:fontRef>
+        </p:style>
+        <p:txBody>
+          <a:bodyPr/>
+          <a:lstStyle/>
+          <a:p>
+            <a:endParaRPr lang="en-US"/>
+          </a:p>
+        </p:txBody>
+      </p:sp>
+      <p:sp>
+        <p:nvSpPr>
+          <p:cNvPr id="5" name="Content Placeholder 2">
+            <a:extLst>
+              <a:ext uri="{FF2B5EF4-FFF2-40B4-BE49-F238E27FC236}">
+                <a16:creationId xmlns:a16="http://schemas.microsoft.com/office/drawing/2014/main" id="{B9240816-1983-70B6-4558-33D0D444B91F}"/>
+              </a:ext>
+            </a:extLst>
+          </p:cNvPr>
+          <p:cNvSpPr txBox="1">
+            <a:spLocks/>
+          </p:cNvSpPr>
+          <p:nvPr/>
+        </p:nvSpPr>
+        <p:spPr>
+          <a:xfrm>
+            <a:off x="4991082" y="4905103"/>
+            <a:ext cx="6813248" cy="1718949"/>
+          </a:xfrm>
+          <a:prstGeom prst="rect">
+            <a:avLst/>
+          </a:prstGeom>
+        </p:spPr>
+        <p:txBody>
+          <a:bodyPr vert="horz" lIns="91440" tIns="45720" rIns="91440" bIns="45720" rtlCol="0" anchor="ctr">
+            <a:normAutofit/>
+          </a:bodyPr>
+          <a:lstStyle>
+            <a:lvl1pPr marL="306000" indent="-306000" algn="l" defTabSz="457200" rtl="0" eaLnBrk="1" latinLnBrk="0" hangingPunct="1">
+              <a:spcBef>
+                <a:spcPct val="20000"/>
+              </a:spcBef>
+              <a:spcAft>
+                <a:spcPts val="600"/>
+              </a:spcAft>
+              <a:buClr>
+                <a:schemeClr val="accent2"/>
+              </a:buClr>
+              <a:buSzPct val="92000"/>
+              <a:buFont typeface="Wingdings 2" panose="05020102010507070707" pitchFamily="18" charset="2"/>
+              <a:buChar char=""/>
+              <a:defRPr sz="1800" kern="1200">
+                <a:solidFill>
+                  <a:schemeClr val="tx2"/>
+                </a:solidFill>
+                <a:latin typeface="+mn-lt"/>
+                <a:ea typeface="+mn-ea"/>
+                <a:cs typeface="+mn-cs"/>
+              </a:defRPr>
+            </a:lvl1pPr>
+            <a:lvl2pPr marL="630000" indent="-306000" algn="l" defTabSz="457200" rtl="0" eaLnBrk="1" latinLnBrk="0" hangingPunct="1">
+              <a:spcBef>
+                <a:spcPct val="20000"/>
+              </a:spcBef>
+              <a:spcAft>
+                <a:spcPts val="600"/>
+              </a:spcAft>
+              <a:buClr>
+                <a:schemeClr val="accent2"/>
+              </a:buClr>
+              <a:buSzPct val="92000"/>
+              <a:buFont typeface="Wingdings 2" panose="05020102010507070707" pitchFamily="18" charset="2"/>
+              <a:buChar char=""/>
+              <a:defRPr sz="1600" kern="1200">
+                <a:solidFill>
+                  <a:schemeClr val="tx2"/>
+                </a:solidFill>
+                <a:latin typeface="+mn-lt"/>
+                <a:ea typeface="+mn-ea"/>
+                <a:cs typeface="+mn-cs"/>
+              </a:defRPr>
+            </a:lvl2pPr>
+            <a:lvl3pPr marL="900000" indent="-270000" algn="l" defTabSz="457200" rtl="0" eaLnBrk="1" latinLnBrk="0" hangingPunct="1">
+              <a:spcBef>
+                <a:spcPct val="20000"/>
+              </a:spcBef>
+              <a:spcAft>
+                <a:spcPts val="600"/>
+              </a:spcAft>
+              <a:buClr>
+                <a:schemeClr val="accent2"/>
+              </a:buClr>
+              <a:buSzPct val="92000"/>
+              <a:buFont typeface="Wingdings 2" panose="05020102010507070707" pitchFamily="18" charset="2"/>
+              <a:buChar char=""/>
+              <a:defRPr sz="1400" kern="1200">
+                <a:solidFill>
+                  <a:schemeClr val="tx2"/>
+                </a:solidFill>
+                <a:latin typeface="+mn-lt"/>
+                <a:ea typeface="+mn-ea"/>
+                <a:cs typeface="+mn-cs"/>
+              </a:defRPr>
+            </a:lvl3pPr>
+            <a:lvl4pPr marL="1242000" indent="-234000" algn="l" defTabSz="457200" rtl="0" eaLnBrk="1" latinLnBrk="0" hangingPunct="1">
+              <a:spcBef>
+                <a:spcPct val="20000"/>
+              </a:spcBef>
+              <a:spcAft>
+                <a:spcPts val="600"/>
+              </a:spcAft>
+              <a:buClr>
+                <a:schemeClr val="accent2"/>
+              </a:buClr>
+              <a:buSzPct val="92000"/>
+              <a:buFont typeface="Wingdings 2" panose="05020102010507070707" pitchFamily="18" charset="2"/>
+              <a:buChar char=""/>
+              <a:defRPr sz="1200" kern="1200">
+                <a:solidFill>
+                  <a:schemeClr val="tx2"/>
+                </a:solidFill>
+                <a:latin typeface="+mn-lt"/>
+                <a:ea typeface="+mn-ea"/>
+                <a:cs typeface="+mn-cs"/>
+              </a:defRPr>
+            </a:lvl4pPr>
+            <a:lvl5pPr marL="1602000" indent="-234000" algn="l" defTabSz="457200" rtl="0" eaLnBrk="1" latinLnBrk="0" hangingPunct="1">
+              <a:spcBef>
+                <a:spcPct val="20000"/>
+              </a:spcBef>
+              <a:spcAft>
+                <a:spcPts val="600"/>
+              </a:spcAft>
+              <a:buClr>
+                <a:schemeClr val="accent2"/>
+              </a:buClr>
+              <a:buSzPct val="92000"/>
+              <a:buFont typeface="Wingdings 2" panose="05020102010507070707" pitchFamily="18" charset="2"/>
+              <a:buChar char=""/>
+              <a:defRPr sz="1200" kern="1200">
+                <a:solidFill>
+                  <a:schemeClr val="tx2"/>
+                </a:solidFill>
+                <a:latin typeface="+mn-lt"/>
+                <a:ea typeface="+mn-ea"/>
+                <a:cs typeface="+mn-cs"/>
+              </a:defRPr>
+            </a:lvl5pPr>
+            <a:lvl6pPr marL="1900000" indent="-228600" algn="l" defTabSz="457200" rtl="0" eaLnBrk="1" latinLnBrk="0" hangingPunct="1">
+              <a:spcBef>
+                <a:spcPct val="20000"/>
+              </a:spcBef>
+              <a:spcAft>
+                <a:spcPts val="600"/>
+              </a:spcAft>
+              <a:buClr>
+                <a:schemeClr val="accent2"/>
+              </a:buClr>
+              <a:buSzPct val="92000"/>
+              <a:buFont typeface="Wingdings 2" panose="05020102010507070707" pitchFamily="18" charset="2"/>
+              <a:buChar char=""/>
+              <a:defRPr sz="1200" kern="1200">
+                <a:solidFill>
+                  <a:schemeClr val="tx2"/>
+                </a:solidFill>
+                <a:latin typeface="+mn-lt"/>
+                <a:ea typeface="+mn-ea"/>
+                <a:cs typeface="+mn-cs"/>
+              </a:defRPr>
+            </a:lvl6pPr>
+            <a:lvl7pPr marL="2200000" indent="-228600" algn="l" defTabSz="457200" rtl="0" eaLnBrk="1" latinLnBrk="0" hangingPunct="1">
+              <a:spcBef>
+                <a:spcPct val="20000"/>
+              </a:spcBef>
+              <a:spcAft>
+                <a:spcPts val="600"/>
+              </a:spcAft>
+              <a:buClr>
+                <a:schemeClr val="accent2"/>
+              </a:buClr>
+              <a:buSzPct val="92000"/>
+              <a:buFont typeface="Wingdings 2" panose="05020102010507070707" pitchFamily="18" charset="2"/>
+              <a:buChar char=""/>
+              <a:defRPr sz="1200" kern="1200">
+                <a:solidFill>
+                  <a:schemeClr val="tx2"/>
+                </a:solidFill>
+                <a:latin typeface="+mn-lt"/>
+                <a:ea typeface="+mn-ea"/>
+                <a:cs typeface="+mn-cs"/>
+              </a:defRPr>
+            </a:lvl7pPr>
+            <a:lvl8pPr marL="2500000" indent="-228600" algn="l" defTabSz="457200" rtl="0" eaLnBrk="1" latinLnBrk="0" hangingPunct="1">
+              <a:spcBef>
+                <a:spcPct val="20000"/>
+              </a:spcBef>
+              <a:spcAft>
+                <a:spcPts val="600"/>
+              </a:spcAft>
+              <a:buClr>
+                <a:schemeClr val="accent2"/>
+              </a:buClr>
+              <a:buSzPct val="92000"/>
+              <a:buFont typeface="Wingdings 2" panose="05020102010507070707" pitchFamily="18" charset="2"/>
+              <a:buChar char=""/>
+              <a:defRPr sz="1200" kern="1200">
+                <a:solidFill>
+                  <a:schemeClr val="tx2"/>
+                </a:solidFill>
+                <a:latin typeface="+mn-lt"/>
+                <a:ea typeface="+mn-ea"/>
+                <a:cs typeface="+mn-cs"/>
+              </a:defRPr>
+            </a:lvl8pPr>
+            <a:lvl9pPr marL="2800000" indent="-228600" algn="l" defTabSz="457200" rtl="0" eaLnBrk="1" latinLnBrk="0" hangingPunct="1">
+              <a:spcBef>
+                <a:spcPct val="20000"/>
+              </a:spcBef>
+              <a:spcAft>
+                <a:spcPts val="600"/>
+              </a:spcAft>
+              <a:buClr>
+                <a:schemeClr val="accent2"/>
+              </a:buClr>
+              <a:buSzPct val="92000"/>
+              <a:buFont typeface="Wingdings 2" panose="05020102010507070707" pitchFamily="18" charset="2"/>
+              <a:buChar char=""/>
+              <a:defRPr sz="1200" kern="1200">
+                <a:solidFill>
+                  <a:schemeClr val="tx2"/>
+                </a:solidFill>
+                <a:latin typeface="+mn-lt"/>
+                <a:ea typeface="+mn-ea"/>
+                <a:cs typeface="+mn-cs"/>
+              </a:defRPr>
+            </a:lvl9pPr>
+          </a:lstStyle>
+          <a:p>
+            <a:r>
+              <a:rPr lang="en-US" dirty="0">
+                <a:solidFill>
+                  <a:srgbClr val="FFFFFF"/>
+                </a:solidFill>
+              </a:rPr>
+              <a:t>Specific to low-acuity patients to get them in and out of the ED quickly</a:t>
+            </a:r>
+          </a:p>
+          <a:p>
+            <a:r>
+              <a:rPr lang="en-US" dirty="0">
+                <a:solidFill>
+                  <a:srgbClr val="FFFFFF"/>
+                </a:solidFill>
+              </a:rPr>
+              <a:t>Beneficial for waiting room occupancy, patient satisfaction, and length of stay for all patients</a:t>
+            </a:r>
+          </a:p>
+        </p:txBody>
+      </p:sp>
+    </p:spTree>
+    <p:extLst>
+      <p:ext uri="{BB962C8B-B14F-4D97-AF65-F5344CB8AC3E}">
+        <p14:creationId xmlns:p14="http://schemas.microsoft.com/office/powerpoint/2010/main" val="1867032432"/>
+      </p:ext>
+    </p:extLst>
+  </p:cSld>
+  <p:clrMapOvr>
     <a:masterClrMapping/>
+  </p:clrMapOvr>
+</p:sld>
+</file>
+
+<file path=ppt/slides/slide4.xml><?xml version="1.0" encoding="utf-8"?>
+<p:sld xmlns:a="http://schemas.openxmlformats.org/drawingml/2006/main" xmlns:r="http://schemas.openxmlformats.org/officeDocument/2006/relationships" xmlns:p="http://schemas.openxmlformats.org/presentationml/2006/main">
+  <p:cSld>
+    <p:bg>
+      <p:bgPr>
+        <a:solidFill>
+          <a:schemeClr val="bg1"/>
+        </a:solidFill>
+        <a:effectLst/>
+      </p:bgPr>
+    </p:bg>
+    <p:spTree>
+      <p:nvGrpSpPr>
+        <p:cNvPr id="1" name=""/>
+        <p:cNvGrpSpPr/>
+        <p:nvPr/>
+      </p:nvGrpSpPr>
+      <p:grpSpPr>
+        <a:xfrm>
+          <a:off x="0" y="0"/>
+          <a:ext cx="0" cy="0"/>
+          <a:chOff x="0" y="0"/>
+          <a:chExt cx="0" cy="0"/>
+        </a:xfrm>
+      </p:grpSpPr>
+      <p:pic>
+        <p:nvPicPr>
+          <p:cNvPr id="4100" name="Picture 4" descr="Emergency Department | Stanford Health Care">
+            <a:extLst>
+              <a:ext uri="{FF2B5EF4-FFF2-40B4-BE49-F238E27FC236}">
+                <a16:creationId xmlns:a16="http://schemas.microsoft.com/office/drawing/2014/main" id="{C208B9F0-3419-9D76-7FBD-A54D47C9D0CD}"/>
+              </a:ext>
+            </a:extLst>
+          </p:cNvPr>
+          <p:cNvPicPr>
+            <a:picLocks noChangeAspect="1" noChangeArrowheads="1"/>
+          </p:cNvPicPr>
+          <p:nvPr/>
+        </p:nvPicPr>
+        <p:blipFill>
+          <a:blip r:embed="rId2">
+            <a:extLst>
+              <a:ext uri="{28A0092B-C50C-407E-A947-70E740481C1C}">
+                <a14:useLocalDpi xmlns:a14="http://schemas.microsoft.com/office/drawing/2010/main" val="0"/>
+              </a:ext>
+            </a:extLst>
+          </a:blip>
+          <a:srcRect l="10985" r="14436" b="1"/>
+          <a:stretch/>
+        </p:blipFill>
+        <p:spPr bwMode="auto">
+          <a:xfrm>
+            <a:off x="20" y="11"/>
+            <a:ext cx="4578252" cy="2608957"/>
+          </a:xfrm>
+          <a:prstGeom prst="rect">
+            <a:avLst/>
+          </a:prstGeom>
+          <a:noFill/>
+          <a:extLst>
+            <a:ext uri="{909E8E84-426E-40DD-AFC4-6F175D3DCCD1}">
+              <a14:hiddenFill xmlns:a14="http://schemas.microsoft.com/office/drawing/2010/main">
+                <a:solidFill>
+                  <a:srgbClr val="FFFFFF"/>
+                </a:solidFill>
+              </a14:hiddenFill>
+            </a:ext>
+          </a:extLst>
+        </p:spPr>
+      </p:pic>
+      <p:sp>
+        <p:nvSpPr>
+          <p:cNvPr id="4112" name="Rectangle 4111">
+            <a:extLst>
+              <a:ext uri="{FF2B5EF4-FFF2-40B4-BE49-F238E27FC236}">
+                <a16:creationId xmlns:a16="http://schemas.microsoft.com/office/drawing/2014/main" id="{B1ACEF87-056E-4E77-899B-9E9A04E9B574}"/>
+              </a:ext>
+              <a:ext uri="{C183D7F6-B498-43B3-948B-1728B52AA6E4}">
+                <adec:decorative xmlns:adec="http://schemas.microsoft.com/office/drawing/2017/decorative" val="1"/>
+              </a:ext>
+            </a:extLst>
+          </p:cNvPr>
+          <p:cNvSpPr>
+            <a:spLocks noGrp="1" noRot="1" noChangeAspect="1" noMove="1" noResize="1" noEditPoints="1" noAdjustHandles="1" noChangeArrowheads="1" noChangeShapeType="1" noTextEdit="1"/>
+          </p:cNvSpPr>
+          <p:nvPr>
+            <p:extLst>
+              <p:ext uri="{386F3935-93C4-4BCD-93E2-E3B085C9AB24}">
+                <p16:designElem xmlns:p16="http://schemas.microsoft.com/office/powerpoint/2015/main" val="1"/>
+              </p:ext>
+            </p:extLst>
+          </p:nvPr>
+        </p:nvSpPr>
+        <p:spPr>
+          <a:xfrm>
+            <a:off x="0" y="2611819"/>
+            <a:ext cx="4576634" cy="4235946"/>
+          </a:xfrm>
+          <a:prstGeom prst="rect">
+            <a:avLst/>
+          </a:prstGeom>
+          <a:solidFill>
+            <a:schemeClr val="accent1"/>
+          </a:solidFill>
+          <a:ln w="6350" cmpd="sng">
+            <a:noFill/>
+          </a:ln>
+          <a:effectLst/>
+        </p:spPr>
+        <p:style>
+          <a:lnRef idx="1">
+            <a:schemeClr val="accent1"/>
+          </a:lnRef>
+          <a:fillRef idx="3">
+            <a:schemeClr val="accent1"/>
+          </a:fillRef>
+          <a:effectRef idx="2">
+            <a:schemeClr val="accent1"/>
+          </a:effectRef>
+          <a:fontRef idx="minor">
+            <a:schemeClr val="lt1"/>
+          </a:fontRef>
+        </p:style>
+        <p:txBody>
+          <a:bodyPr/>
+          <a:lstStyle/>
+          <a:p>
+            <a:endParaRPr lang="en-US"/>
+          </a:p>
+        </p:txBody>
+      </p:sp>
+      <p:sp>
+        <p:nvSpPr>
+          <p:cNvPr id="2" name="Title 1">
+            <a:extLst>
+              <a:ext uri="{FF2B5EF4-FFF2-40B4-BE49-F238E27FC236}">
+                <a16:creationId xmlns:a16="http://schemas.microsoft.com/office/drawing/2014/main" id="{3306C0D6-F36D-C05F-7433-D950D1700529}"/>
+              </a:ext>
+            </a:extLst>
+          </p:cNvPr>
+          <p:cNvSpPr>
+            <a:spLocks noGrp="1"/>
+          </p:cNvSpPr>
+          <p:nvPr>
+            <p:ph type="title"/>
+          </p:nvPr>
+        </p:nvSpPr>
+        <p:spPr>
+          <a:xfrm>
+            <a:off x="49950" y="2701771"/>
+            <a:ext cx="3412067" cy="897047"/>
+          </a:xfrm>
+        </p:spPr>
+        <p:txBody>
+          <a:bodyPr anchor="ctr">
+            <a:normAutofit/>
+          </a:bodyPr>
+          <a:lstStyle/>
+          <a:p>
+            <a:r>
+              <a:rPr lang="en-US" dirty="0">
+                <a:solidFill>
+                  <a:srgbClr val="FFFFFF"/>
+                </a:solidFill>
+              </a:rPr>
+              <a:t>MC-MED Dataset</a:t>
+            </a:r>
+          </a:p>
+        </p:txBody>
+      </p:sp>
+      <p:sp>
+        <p:nvSpPr>
+          <p:cNvPr id="3" name="Content Placeholder 2">
+            <a:extLst>
+              <a:ext uri="{FF2B5EF4-FFF2-40B4-BE49-F238E27FC236}">
+                <a16:creationId xmlns:a16="http://schemas.microsoft.com/office/drawing/2014/main" id="{11311548-2A0D-2526-47EE-A420329060DD}"/>
+              </a:ext>
+            </a:extLst>
+          </p:cNvPr>
+          <p:cNvSpPr>
+            <a:spLocks noGrp="1"/>
+          </p:cNvSpPr>
+          <p:nvPr>
+            <p:ph idx="1"/>
+          </p:nvPr>
+        </p:nvSpPr>
+        <p:spPr>
+          <a:xfrm>
+            <a:off x="49950" y="3782108"/>
+            <a:ext cx="4253628" cy="2401980"/>
+          </a:xfrm>
+        </p:spPr>
+        <p:txBody>
+          <a:bodyPr>
+            <a:normAutofit/>
+          </a:bodyPr>
+          <a:lstStyle/>
+          <a:p>
+            <a:r>
+              <a:rPr lang="en-US" dirty="0">
+                <a:solidFill>
+                  <a:srgbClr val="FFFFFF"/>
+                </a:solidFill>
+              </a:rPr>
+              <a:t>Published on PhysioNet March 3, 2025</a:t>
+            </a:r>
+            <a:br>
+              <a:rPr lang="en-US" dirty="0">
+                <a:solidFill>
+                  <a:srgbClr val="FFFFFF"/>
+                </a:solidFill>
+              </a:rPr>
+            </a:br>
+            <a:endParaRPr lang="en-US" dirty="0">
+              <a:solidFill>
+                <a:srgbClr val="FFFFFF"/>
+              </a:solidFill>
+            </a:endParaRPr>
+          </a:p>
+          <a:p>
+            <a:r>
+              <a:rPr lang="en-US" dirty="0">
+                <a:solidFill>
+                  <a:srgbClr val="FFFFFF"/>
+                </a:solidFill>
+              </a:rPr>
+              <a:t>Multi-modal ED data from Stanford Adult ED from 2020-2022</a:t>
+            </a:r>
+            <a:br>
+              <a:rPr lang="en-US" dirty="0">
+                <a:solidFill>
+                  <a:srgbClr val="FFFFFF"/>
+                </a:solidFill>
+              </a:rPr>
+            </a:br>
+            <a:endParaRPr lang="en-US" dirty="0">
+              <a:solidFill>
+                <a:srgbClr val="FFFFFF"/>
+              </a:solidFill>
+            </a:endParaRPr>
+          </a:p>
+          <a:p>
+            <a:r>
+              <a:rPr lang="en-US" dirty="0">
+                <a:solidFill>
+                  <a:srgbClr val="FFFFFF"/>
+                </a:solidFill>
+              </a:rPr>
+              <a:t>Pre-defined train, validation, and test splits that keep patients consistent</a:t>
+            </a:r>
+          </a:p>
+        </p:txBody>
+      </p:sp>
+      <p:pic>
+        <p:nvPicPr>
+          <p:cNvPr id="4102" name="Picture 6" descr="Separate Adult and Pediatric Emergency Departments - Stanford Medicine  Children's Health">
+            <a:extLst>
+              <a:ext uri="{FF2B5EF4-FFF2-40B4-BE49-F238E27FC236}">
+                <a16:creationId xmlns:a16="http://schemas.microsoft.com/office/drawing/2014/main" id="{492B4BFB-FB76-424A-9337-660D168A51BA}"/>
+              </a:ext>
+            </a:extLst>
+          </p:cNvPr>
+          <p:cNvPicPr>
+            <a:picLocks noChangeAspect="1" noChangeArrowheads="1"/>
+          </p:cNvPicPr>
+          <p:nvPr/>
+        </p:nvPicPr>
+        <p:blipFill>
+          <a:blip r:embed="rId3">
+            <a:extLst>
+              <a:ext uri="{28A0092B-C50C-407E-A947-70E740481C1C}">
+                <a14:useLocalDpi xmlns:a14="http://schemas.microsoft.com/office/drawing/2010/main" val="0"/>
+              </a:ext>
+            </a:extLst>
+          </a:blip>
+          <a:srcRect l="4520" r="12215"/>
+          <a:stretch/>
+        </p:blipFill>
+        <p:spPr bwMode="auto">
+          <a:xfrm>
+            <a:off x="4578270" y="-11"/>
+            <a:ext cx="7613730" cy="6858000"/>
+          </a:xfrm>
+          <a:prstGeom prst="rect">
+            <a:avLst/>
+          </a:prstGeom>
+          <a:noFill/>
+          <a:extLst>
+            <a:ext uri="{909E8E84-426E-40DD-AFC4-6F175D3DCCD1}">
+              <a14:hiddenFill xmlns:a14="http://schemas.microsoft.com/office/drawing/2010/main">
+                <a:solidFill>
+                  <a:srgbClr val="FFFFFF"/>
+                </a:solidFill>
+              </a14:hiddenFill>
+            </a:ext>
+          </a:extLst>
+        </p:spPr>
+      </p:pic>
+      <p:sp>
+        <p:nvSpPr>
+          <p:cNvPr id="4114" name="Rectangle 4113">
+            <a:extLst>
+              <a:ext uri="{FF2B5EF4-FFF2-40B4-BE49-F238E27FC236}">
+                <a16:creationId xmlns:a16="http://schemas.microsoft.com/office/drawing/2014/main" id="{DD0C6C3A-73B1-4E33-AD0D-8BCD35B714CD}"/>
+              </a:ext>
+              <a:ext uri="{C183D7F6-B498-43B3-948B-1728B52AA6E4}">
+                <adec:decorative xmlns:adec="http://schemas.microsoft.com/office/drawing/2017/decorative" val="1"/>
+              </a:ext>
+            </a:extLst>
+          </p:cNvPr>
+          <p:cNvSpPr>
+            <a:spLocks noGrp="1" noRot="1" noChangeAspect="1" noMove="1" noResize="1" noEditPoints="1" noAdjustHandles="1" noChangeArrowheads="1" noChangeShapeType="1" noTextEdit="1"/>
+          </p:cNvSpPr>
+          <p:nvPr>
+            <p:extLst>
+              <p:ext uri="{386F3935-93C4-4BCD-93E2-E3B085C9AB24}">
+                <p16:designElem xmlns:p16="http://schemas.microsoft.com/office/powerpoint/2015/main" val="1"/>
+              </p:ext>
+            </p:extLst>
+          </p:nvPr>
+        </p:nvSpPr>
+        <p:spPr>
+          <a:xfrm>
+            <a:off x="4530517" y="-460"/>
+            <a:ext cx="91440" cy="6858000"/>
+          </a:xfrm>
+          <a:prstGeom prst="rect">
+            <a:avLst/>
+          </a:prstGeom>
+          <a:solidFill>
+            <a:srgbClr val="FFFFFF"/>
+          </a:solidFill>
+          <a:ln>
+            <a:noFill/>
+          </a:ln>
+          <a:effectLst/>
+        </p:spPr>
+        <p:style>
+          <a:lnRef idx="1">
+            <a:schemeClr val="accent1"/>
+          </a:lnRef>
+          <a:fillRef idx="3">
+            <a:schemeClr val="accent1"/>
+          </a:fillRef>
+          <a:effectRef idx="2">
+            <a:schemeClr val="accent1"/>
+          </a:effectRef>
+          <a:fontRef idx="minor">
+            <a:schemeClr val="lt1"/>
+          </a:fontRef>
+        </p:style>
+        <p:txBody>
+          <a:bodyPr rtlCol="0" anchor="ctr"/>
+          <a:lstStyle/>
+          <a:p>
+            <a:pPr algn="ctr"/>
+            <a:endParaRPr lang="en-US"/>
+          </a:p>
+        </p:txBody>
+      </p:sp>
+      <p:sp>
+        <p:nvSpPr>
+          <p:cNvPr id="4116" name="Rectangle 4115">
+            <a:extLst>
+              <a:ext uri="{FF2B5EF4-FFF2-40B4-BE49-F238E27FC236}">
+                <a16:creationId xmlns:a16="http://schemas.microsoft.com/office/drawing/2014/main" id="{303022F3-BFF5-4104-AE9A-399949DAFC26}"/>
+              </a:ext>
+              <a:ext uri="{C183D7F6-B498-43B3-948B-1728B52AA6E4}">
+                <adec:decorative xmlns:adec="http://schemas.microsoft.com/office/drawing/2017/decorative" val="1"/>
+              </a:ext>
+            </a:extLst>
+          </p:cNvPr>
+          <p:cNvSpPr>
+            <a:spLocks noGrp="1" noRot="1" noChangeAspect="1" noMove="1" noResize="1" noEditPoints="1" noAdjustHandles="1" noChangeArrowheads="1" noChangeShapeType="1" noTextEdit="1"/>
+          </p:cNvSpPr>
+          <p:nvPr>
+            <p:extLst>
+              <p:ext uri="{386F3935-93C4-4BCD-93E2-E3B085C9AB24}">
+                <p16:designElem xmlns:p16="http://schemas.microsoft.com/office/powerpoint/2015/main" val="1"/>
+              </p:ext>
+            </p:extLst>
+          </p:nvPr>
+        </p:nvSpPr>
+        <p:spPr>
+          <a:xfrm>
+            <a:off x="-139" y="2560620"/>
+            <a:ext cx="4581144" cy="91440"/>
+          </a:xfrm>
+          <a:prstGeom prst="rect">
+            <a:avLst/>
+          </a:prstGeom>
+          <a:solidFill>
+            <a:srgbClr val="FFFFFF"/>
+          </a:solidFill>
+          <a:ln>
+            <a:noFill/>
+          </a:ln>
+          <a:effectLst/>
+        </p:spPr>
+        <p:style>
+          <a:lnRef idx="1">
+            <a:schemeClr val="accent1"/>
+          </a:lnRef>
+          <a:fillRef idx="3">
+            <a:schemeClr val="accent1"/>
+          </a:fillRef>
+          <a:effectRef idx="2">
+            <a:schemeClr val="accent1"/>
+          </a:effectRef>
+          <a:fontRef idx="minor">
+            <a:schemeClr val="lt1"/>
+          </a:fontRef>
+        </p:style>
+        <p:txBody>
+          <a:bodyPr/>
+          <a:lstStyle/>
+          <a:p>
+            <a:endParaRPr lang="en-US"/>
+          </a:p>
+        </p:txBody>
+      </p:sp>
+    </p:spTree>
+    <p:extLst>
+      <p:ext uri="{BB962C8B-B14F-4D97-AF65-F5344CB8AC3E}">
+        <p14:creationId xmlns:p14="http://schemas.microsoft.com/office/powerpoint/2010/main" val="3787716770"/>
+      </p:ext>
+    </p:extLst>
+  </p:cSld>
+  <p:clrMapOvr>
+    <a:overrideClrMapping bg1="dk1" tx1="lt1" bg2="dk2" tx2="lt2" accent1="accent1" accent2="accent2" accent3="accent3" accent4="accent4" accent5="accent5" accent6="accent6" hlink="hlink" folHlink="folHlink"/>
+  </p:clrMapOvr>
+</p:sld>
+</file>
+
+<file path=ppt/slides/slide5.xml><?xml version="1.0" encoding="utf-8"?>
+<p:sld xmlns:a="http://schemas.openxmlformats.org/drawingml/2006/main" xmlns:r="http://schemas.openxmlformats.org/officeDocument/2006/relationships" xmlns:p="http://schemas.openxmlformats.org/presentationml/2006/main">
+  <p:cSld>
+    <p:spTree>
+      <p:nvGrpSpPr>
+        <p:cNvPr id="1" name=""/>
+        <p:cNvGrpSpPr/>
+        <p:nvPr/>
+      </p:nvGrpSpPr>
+      <p:grpSpPr>
+        <a:xfrm>
+          <a:off x="0" y="0"/>
+          <a:ext cx="0" cy="0"/>
+          <a:chOff x="0" y="0"/>
+          <a:chExt cx="0" cy="0"/>
+        </a:xfrm>
+      </p:grpSpPr>
+      <p:sp>
+        <p:nvSpPr>
+          <p:cNvPr id="2" name="Title 1">
+            <a:extLst>
+              <a:ext uri="{FF2B5EF4-FFF2-40B4-BE49-F238E27FC236}">
+                <a16:creationId xmlns:a16="http://schemas.microsoft.com/office/drawing/2014/main" id="{BC4CF0E1-A2F6-CD3E-30B2-8F73B1539842}"/>
+              </a:ext>
+            </a:extLst>
+          </p:cNvPr>
+          <p:cNvSpPr>
+            <a:spLocks noGrp="1"/>
+          </p:cNvSpPr>
+          <p:nvPr>
+            <p:ph type="title"/>
+          </p:nvPr>
+        </p:nvSpPr>
+        <p:spPr/>
+        <p:txBody>
+          <a:bodyPr/>
+          <a:lstStyle/>
+          <a:p>
+            <a:r>
+              <a:rPr lang="en-US" dirty="0"/>
+              <a:t>Fast-Track Eligibility Prediction</a:t>
+            </a:r>
+          </a:p>
+        </p:txBody>
+      </p:sp>
+      <p:pic>
+        <p:nvPicPr>
+          <p:cNvPr id="5" name="Content Placeholder 4">
+            <a:extLst>
+              <a:ext uri="{FF2B5EF4-FFF2-40B4-BE49-F238E27FC236}">
+                <a16:creationId xmlns:a16="http://schemas.microsoft.com/office/drawing/2014/main" id="{A9511FB5-FF8A-F5C0-7B4A-781805D6A5D8}"/>
+              </a:ext>
+            </a:extLst>
+          </p:cNvPr>
+          <p:cNvPicPr>
+            <a:picLocks noGrp="1" noChangeAspect="1"/>
+          </p:cNvPicPr>
+          <p:nvPr>
+            <p:ph idx="1"/>
+          </p:nvPr>
+        </p:nvPicPr>
+        <p:blipFill>
+          <a:blip r:embed="rId2">
+            <a:extLst>
+              <a:ext uri="{96DAC541-7B7A-43D3-8B79-37D633B846F1}">
+                <asvg:svgBlip xmlns:asvg="http://schemas.microsoft.com/office/drawing/2016/SVG/main" r:embed="rId3"/>
+              </a:ext>
+            </a:extLst>
+          </a:blip>
+          <a:stretch>
+            <a:fillRect/>
+          </a:stretch>
+        </p:blipFill>
+        <p:spPr>
+          <a:xfrm>
+            <a:off x="581025" y="2308800"/>
+            <a:ext cx="11029950" cy="3423087"/>
+          </a:xfrm>
+        </p:spPr>
+      </p:pic>
+    </p:spTree>
+    <p:extLst>
+      <p:ext uri="{BB962C8B-B14F-4D97-AF65-F5344CB8AC3E}">
+        <p14:creationId xmlns:p14="http://schemas.microsoft.com/office/powerpoint/2010/main" val="4150595000"/>
+      </p:ext>
+    </p:extLst>
+  </p:cSld>
+  <p:clrMapOvr>
+    <a:masterClrMapping/>
+  </p:clrMapOvr>
+</p:sld>
+</file>
+
+<file path=ppt/slides/slide6.xml><?xml version="1.0" encoding="utf-8"?>
+<p:sld xmlns:a="http://schemas.openxmlformats.org/drawingml/2006/main" xmlns:r="http://schemas.openxmlformats.org/officeDocument/2006/relationships" xmlns:p="http://schemas.openxmlformats.org/presentationml/2006/main">
+  <p:cSld>
+    <p:spTree>
+      <p:nvGrpSpPr>
+        <p:cNvPr id="1" name=""/>
+        <p:cNvGrpSpPr/>
+        <p:nvPr/>
+      </p:nvGrpSpPr>
+      <p:grpSpPr>
+        <a:xfrm>
+          <a:off x="0" y="0"/>
+          <a:ext cx="0" cy="0"/>
+          <a:chOff x="0" y="0"/>
+          <a:chExt cx="0" cy="0"/>
+        </a:xfrm>
+      </p:grpSpPr>
+      <p:sp>
+        <p:nvSpPr>
+          <p:cNvPr id="2" name="Title 1">
+            <a:extLst>
+              <a:ext uri="{FF2B5EF4-FFF2-40B4-BE49-F238E27FC236}">
+                <a16:creationId xmlns:a16="http://schemas.microsoft.com/office/drawing/2014/main" id="{BA2FED74-ADC4-B968-911D-1636B83538FD}"/>
+              </a:ext>
+            </a:extLst>
+          </p:cNvPr>
+          <p:cNvSpPr>
+            <a:spLocks noGrp="1"/>
+          </p:cNvSpPr>
+          <p:nvPr>
+            <p:ph type="title"/>
+          </p:nvPr>
+        </p:nvSpPr>
+        <p:spPr/>
+        <p:txBody>
+          <a:bodyPr/>
+          <a:lstStyle/>
+          <a:p>
+            <a:r>
+              <a:rPr lang="en-US" dirty="0"/>
+              <a:t>Results – ROC-AUC</a:t>
+            </a:r>
+          </a:p>
+        </p:txBody>
+      </p:sp>
+      <p:pic>
+        <p:nvPicPr>
+          <p:cNvPr id="9" name="Content Placeholder 8" descr="A graph of a curve&#10;&#10;AI-generated content may be incorrect.">
+            <a:extLst>
+              <a:ext uri="{FF2B5EF4-FFF2-40B4-BE49-F238E27FC236}">
+                <a16:creationId xmlns:a16="http://schemas.microsoft.com/office/drawing/2014/main" id="{BA8574ED-A9AB-C1D5-87A8-475740FC3BD4}"/>
+              </a:ext>
+            </a:extLst>
+          </p:cNvPr>
+          <p:cNvPicPr>
+            <a:picLocks noGrp="1" noChangeAspect="1"/>
+          </p:cNvPicPr>
+          <p:nvPr>
+            <p:ph idx="1"/>
+          </p:nvPr>
+        </p:nvPicPr>
+        <p:blipFill>
+          <a:blip r:embed="rId2"/>
+          <a:stretch>
+            <a:fillRect/>
+          </a:stretch>
+        </p:blipFill>
+        <p:spPr>
+          <a:xfrm>
+            <a:off x="383474" y="1972328"/>
+            <a:ext cx="5155931" cy="4288579"/>
+          </a:xfrm>
+        </p:spPr>
+      </p:pic>
+      <p:pic>
+        <p:nvPicPr>
+          <p:cNvPr id="11" name="Picture 10" descr="A group of colorful bars&#10;&#10;AI-generated content may be incorrect.">
+            <a:extLst>
+              <a:ext uri="{FF2B5EF4-FFF2-40B4-BE49-F238E27FC236}">
+                <a16:creationId xmlns:a16="http://schemas.microsoft.com/office/drawing/2014/main" id="{6C783500-504F-94FD-0DED-EA5306169BBE}"/>
+              </a:ext>
+            </a:extLst>
+          </p:cNvPr>
+          <p:cNvPicPr>
+            <a:picLocks noChangeAspect="1"/>
+          </p:cNvPicPr>
+          <p:nvPr/>
+        </p:nvPicPr>
+        <p:blipFill>
+          <a:blip r:embed="rId3"/>
+          <a:stretch>
+            <a:fillRect/>
+          </a:stretch>
+        </p:blipFill>
+        <p:spPr>
+          <a:xfrm>
+            <a:off x="5667936" y="2077393"/>
+            <a:ext cx="6140590" cy="4078451"/>
+          </a:xfrm>
+          <a:prstGeom prst="rect">
+            <a:avLst/>
+          </a:prstGeom>
+        </p:spPr>
+      </p:pic>
+    </p:spTree>
+    <p:extLst>
+      <p:ext uri="{BB962C8B-B14F-4D97-AF65-F5344CB8AC3E}">
+        <p14:creationId xmlns:p14="http://schemas.microsoft.com/office/powerpoint/2010/main" val="504275428"/>
+      </p:ext>
+    </p:extLst>
+  </p:cSld>
+  <p:clrMapOvr>
+    <a:masterClrMapping/>
+  </p:clrMapOvr>
+</p:sld>
+</file>
+
+<file path=ppt/slides/slide7.xml><?xml version="1.0" encoding="utf-8"?>
+<p:sld xmlns:a="http://schemas.openxmlformats.org/drawingml/2006/main" xmlns:r="http://schemas.openxmlformats.org/officeDocument/2006/relationships" xmlns:p="http://schemas.openxmlformats.org/presentationml/2006/main">
+  <p:cSld>
+    <p:spTree>
+      <p:nvGrpSpPr>
+        <p:cNvPr id="1" name=""/>
+        <p:cNvGrpSpPr/>
+        <p:nvPr/>
+      </p:nvGrpSpPr>
+      <p:grpSpPr>
+        <a:xfrm>
+          <a:off x="0" y="0"/>
+          <a:ext cx="0" cy="0"/>
+          <a:chOff x="0" y="0"/>
+          <a:chExt cx="0" cy="0"/>
+        </a:xfrm>
+      </p:grpSpPr>
+      <p:sp>
+        <p:nvSpPr>
+          <p:cNvPr id="2" name="Title 1">
+            <a:extLst>
+              <a:ext uri="{FF2B5EF4-FFF2-40B4-BE49-F238E27FC236}">
+                <a16:creationId xmlns:a16="http://schemas.microsoft.com/office/drawing/2014/main" id="{BCD55AA4-F152-43AB-C4EE-76DCA4312325}"/>
+              </a:ext>
+            </a:extLst>
+          </p:cNvPr>
+          <p:cNvSpPr>
+            <a:spLocks noGrp="1"/>
+          </p:cNvSpPr>
+          <p:nvPr>
+            <p:ph type="title"/>
+          </p:nvPr>
+        </p:nvSpPr>
+        <p:spPr/>
+        <p:txBody>
+          <a:bodyPr/>
+          <a:lstStyle/>
+          <a:p>
+            <a:r>
+              <a:rPr lang="en-US" dirty="0"/>
+              <a:t>Results – Feature Importance </a:t>
+            </a:r>
+          </a:p>
+        </p:txBody>
+      </p:sp>
+      <p:pic>
+        <p:nvPicPr>
+          <p:cNvPr id="4" name="Picture 3" descr="A chart of different colored lines&#10;&#10;AI-generated content may be incorrect.">
+            <a:extLst>
+              <a:ext uri="{FF2B5EF4-FFF2-40B4-BE49-F238E27FC236}">
+                <a16:creationId xmlns:a16="http://schemas.microsoft.com/office/drawing/2014/main" id="{68541C11-55E5-E8BA-CCC9-D87F4005FA35}"/>
+              </a:ext>
+            </a:extLst>
+          </p:cNvPr>
+          <p:cNvPicPr>
+            <a:picLocks noChangeAspect="1"/>
+          </p:cNvPicPr>
+          <p:nvPr/>
+        </p:nvPicPr>
+        <p:blipFill>
+          <a:blip r:embed="rId2"/>
+          <a:srcRect l="11319" r="1528" b="-2"/>
+          <a:stretch/>
+        </p:blipFill>
+        <p:spPr>
+          <a:xfrm>
+            <a:off x="6599346" y="2197876"/>
+            <a:ext cx="4908223" cy="3745144"/>
+          </a:xfrm>
+          <a:prstGeom prst="rect">
+            <a:avLst/>
+          </a:prstGeom>
+        </p:spPr>
+      </p:pic>
+      <p:pic>
+        <p:nvPicPr>
+          <p:cNvPr id="7" name="Picture 6" descr="A graph of embedding type importance&#10;&#10;AI-generated content may be incorrect.">
+            <a:extLst>
+              <a:ext uri="{FF2B5EF4-FFF2-40B4-BE49-F238E27FC236}">
+                <a16:creationId xmlns:a16="http://schemas.microsoft.com/office/drawing/2014/main" id="{AC73628B-CEAE-4CA9-E4FF-46CF4409AC1F}"/>
+              </a:ext>
+            </a:extLst>
+          </p:cNvPr>
+          <p:cNvPicPr>
+            <a:picLocks noChangeAspect="1"/>
+          </p:cNvPicPr>
+          <p:nvPr/>
+        </p:nvPicPr>
+        <p:blipFill>
+          <a:blip r:embed="rId3"/>
+          <a:stretch>
+            <a:fillRect/>
+          </a:stretch>
+        </p:blipFill>
+        <p:spPr>
+          <a:xfrm>
+            <a:off x="321187" y="2299974"/>
+            <a:ext cx="5932129" cy="3540948"/>
+          </a:xfrm>
+          <a:prstGeom prst="rect">
+            <a:avLst/>
+          </a:prstGeom>
+        </p:spPr>
+      </p:pic>
+    </p:spTree>
+    <p:extLst>
+      <p:ext uri="{BB962C8B-B14F-4D97-AF65-F5344CB8AC3E}">
+        <p14:creationId xmlns:p14="http://schemas.microsoft.com/office/powerpoint/2010/main" val="953245639"/>
+      </p:ext>
+    </p:extLst>
+  </p:cSld>
+  <p:clrMapOvr>
+    <a:masterClrMapping/>
+  </p:clrMapOvr>
+</p:sld>
+</file>
+
+<file path=ppt/slides/slide8.xml><?xml version="1.0" encoding="utf-8"?>
+<p:sld xmlns:a="http://schemas.openxmlformats.org/drawingml/2006/main" xmlns:r="http://schemas.openxmlformats.org/officeDocument/2006/relationships" xmlns:p="http://schemas.openxmlformats.org/presentationml/2006/main">
+  <p:cSld>
+    <p:bg>
+      <p:bgPr>
+        <a:solidFill>
+          <a:schemeClr val="bg1"/>
+        </a:solidFill>
+        <a:effectLst/>
+      </p:bgPr>
+    </p:bg>
+    <p:spTree>
+      <p:nvGrpSpPr>
+        <p:cNvPr id="1" name=""/>
+        <p:cNvGrpSpPr/>
+        <p:nvPr/>
+      </p:nvGrpSpPr>
+      <p:grpSpPr>
+        <a:xfrm>
+          <a:off x="0" y="0"/>
+          <a:ext cx="0" cy="0"/>
+          <a:chOff x="0" y="0"/>
+          <a:chExt cx="0" cy="0"/>
+        </a:xfrm>
+      </p:grpSpPr>
+      <p:pic>
+        <p:nvPicPr>
+          <p:cNvPr id="5122" name="Picture 2" descr="Part II: Why is the Emergency Department So Crowded? -">
+            <a:extLst>
+              <a:ext uri="{FF2B5EF4-FFF2-40B4-BE49-F238E27FC236}">
+                <a16:creationId xmlns:a16="http://schemas.microsoft.com/office/drawing/2014/main" id="{22258FF3-2FCE-1C51-6299-754A8CCBEBE4}"/>
+              </a:ext>
+            </a:extLst>
+          </p:cNvPr>
+          <p:cNvPicPr>
+            <a:picLocks noChangeAspect="1" noChangeArrowheads="1"/>
+          </p:cNvPicPr>
+          <p:nvPr/>
+        </p:nvPicPr>
+        <p:blipFill>
+          <a:blip r:embed="rId2">
+            <a:extLst>
+              <a:ext uri="{28A0092B-C50C-407E-A947-70E740481C1C}">
+                <a14:useLocalDpi xmlns:a14="http://schemas.microsoft.com/office/drawing/2010/main" val="0"/>
+              </a:ext>
+            </a:extLst>
+          </a:blip>
+          <a:srcRect r="1288" b="-3"/>
+          <a:stretch/>
+        </p:blipFill>
+        <p:spPr bwMode="auto">
+          <a:xfrm>
+            <a:off x="20" y="11"/>
+            <a:ext cx="4578252" cy="2608957"/>
+          </a:xfrm>
+          <a:prstGeom prst="rect">
+            <a:avLst/>
+          </a:prstGeom>
+          <a:noFill/>
+          <a:extLst>
+            <a:ext uri="{909E8E84-426E-40DD-AFC4-6F175D3DCCD1}">
+              <a14:hiddenFill xmlns:a14="http://schemas.microsoft.com/office/drawing/2010/main">
+                <a:solidFill>
+                  <a:srgbClr val="FFFFFF"/>
+                </a:solidFill>
+              </a14:hiddenFill>
+            </a:ext>
+          </a:extLst>
+        </p:spPr>
+      </p:pic>
+      <p:sp>
+        <p:nvSpPr>
+          <p:cNvPr id="5131" name="Rectangle 5130">
+            <a:extLst>
+              <a:ext uri="{FF2B5EF4-FFF2-40B4-BE49-F238E27FC236}">
+                <a16:creationId xmlns:a16="http://schemas.microsoft.com/office/drawing/2014/main" id="{B1ACEF87-056E-4E77-899B-9E9A04E9B574}"/>
+              </a:ext>
+              <a:ext uri="{C183D7F6-B498-43B3-948B-1728B52AA6E4}">
+                <adec:decorative xmlns:adec="http://schemas.microsoft.com/office/drawing/2017/decorative" val="1"/>
+              </a:ext>
+            </a:extLst>
+          </p:cNvPr>
+          <p:cNvSpPr>
+            <a:spLocks noGrp="1" noRot="1" noChangeAspect="1" noMove="1" noResize="1" noEditPoints="1" noAdjustHandles="1" noChangeArrowheads="1" noChangeShapeType="1" noTextEdit="1"/>
+          </p:cNvSpPr>
+          <p:nvPr>
+            <p:extLst>
+              <p:ext uri="{386F3935-93C4-4BCD-93E2-E3B085C9AB24}">
+                <p16:designElem xmlns:p16="http://schemas.microsoft.com/office/powerpoint/2015/main" val="1"/>
+              </p:ext>
+            </p:extLst>
+          </p:nvPr>
+        </p:nvSpPr>
+        <p:spPr>
+          <a:xfrm>
+            <a:off x="0" y="2611819"/>
+            <a:ext cx="4576634" cy="4235946"/>
+          </a:xfrm>
+          <a:prstGeom prst="rect">
+            <a:avLst/>
+          </a:prstGeom>
+          <a:solidFill>
+            <a:schemeClr val="accent1"/>
+          </a:solidFill>
+          <a:ln w="6350" cmpd="sng">
+            <a:noFill/>
+          </a:ln>
+          <a:effectLst/>
+        </p:spPr>
+        <p:style>
+          <a:lnRef idx="1">
+            <a:schemeClr val="accent1"/>
+          </a:lnRef>
+          <a:fillRef idx="3">
+            <a:schemeClr val="accent1"/>
+          </a:fillRef>
+          <a:effectRef idx="2">
+            <a:schemeClr val="accent1"/>
+          </a:effectRef>
+          <a:fontRef idx="minor">
+            <a:schemeClr val="lt1"/>
+          </a:fontRef>
+        </p:style>
+        <p:txBody>
+          <a:bodyPr/>
+          <a:lstStyle/>
+          <a:p>
+            <a:endParaRPr lang="en-US"/>
+          </a:p>
+        </p:txBody>
+      </p:sp>
+      <p:sp>
+        <p:nvSpPr>
+          <p:cNvPr id="2" name="Title 1">
+            <a:extLst>
+              <a:ext uri="{FF2B5EF4-FFF2-40B4-BE49-F238E27FC236}">
+                <a16:creationId xmlns:a16="http://schemas.microsoft.com/office/drawing/2014/main" id="{14B563A8-7BBB-5BDF-1D89-B5E8639D77F5}"/>
+              </a:ext>
+            </a:extLst>
+          </p:cNvPr>
+          <p:cNvSpPr>
+            <a:spLocks noGrp="1"/>
+          </p:cNvSpPr>
+          <p:nvPr>
+            <p:ph type="title"/>
+          </p:nvPr>
+        </p:nvSpPr>
+        <p:spPr>
+          <a:xfrm>
+            <a:off x="267208" y="2825093"/>
+            <a:ext cx="3412067" cy="897047"/>
+          </a:xfrm>
+        </p:spPr>
+        <p:txBody>
+          <a:bodyPr anchor="ctr">
+            <a:normAutofit/>
+          </a:bodyPr>
+          <a:lstStyle/>
+          <a:p>
+            <a:pPr>
+              <a:lnSpc>
+                <a:spcPct val="90000"/>
+              </a:lnSpc>
+            </a:pPr>
+            <a:r>
+              <a:rPr lang="en-US" dirty="0">
+                <a:solidFill>
+                  <a:srgbClr val="FFFFFF"/>
+                </a:solidFill>
+              </a:rPr>
+              <a:t>Future Directions</a:t>
+            </a:r>
+          </a:p>
+        </p:txBody>
+      </p:sp>
+      <p:sp>
+        <p:nvSpPr>
+          <p:cNvPr id="5128" name="Content Placeholder 5127">
+            <a:extLst>
+              <a:ext uri="{FF2B5EF4-FFF2-40B4-BE49-F238E27FC236}">
+                <a16:creationId xmlns:a16="http://schemas.microsoft.com/office/drawing/2014/main" id="{95470E73-E488-37C1-B2DC-1C56FCFEB1FC}"/>
+              </a:ext>
+            </a:extLst>
+          </p:cNvPr>
+          <p:cNvSpPr>
+            <a:spLocks noGrp="1"/>
+          </p:cNvSpPr>
+          <p:nvPr>
+            <p:ph idx="1"/>
+          </p:nvPr>
+        </p:nvSpPr>
+        <p:spPr>
+          <a:xfrm>
+            <a:off x="-1" y="4032907"/>
+            <a:ext cx="4334257" cy="2273340"/>
+          </a:xfrm>
+        </p:spPr>
+        <p:txBody>
+          <a:bodyPr>
+            <a:normAutofit fontScale="92500" lnSpcReduction="10000"/>
+          </a:bodyPr>
+          <a:lstStyle/>
+          <a:p>
+            <a:r>
+              <a:rPr lang="en-US" dirty="0">
+                <a:solidFill>
+                  <a:srgbClr val="FFFFFF"/>
+                </a:solidFill>
+              </a:rPr>
+              <a:t>Train a model with additional modalities (ex.  audio or images)</a:t>
+            </a:r>
+            <a:br>
+              <a:rPr lang="en-US" dirty="0">
+                <a:solidFill>
+                  <a:srgbClr val="FFFFFF"/>
+                </a:solidFill>
+              </a:rPr>
+            </a:br>
+            <a:endParaRPr lang="en-US" dirty="0">
+              <a:solidFill>
+                <a:srgbClr val="FFFFFF"/>
+              </a:solidFill>
+            </a:endParaRPr>
+          </a:p>
+          <a:p>
+            <a:r>
+              <a:rPr lang="en-US" dirty="0">
+                <a:solidFill>
+                  <a:srgbClr val="FFFFFF"/>
+                </a:solidFill>
+              </a:rPr>
+              <a:t>More research into different fast-track criteria</a:t>
+            </a:r>
+            <a:br>
+              <a:rPr lang="en-US" dirty="0">
+                <a:solidFill>
+                  <a:srgbClr val="FFFFFF"/>
+                </a:solidFill>
+              </a:rPr>
+            </a:br>
+            <a:endParaRPr lang="en-US" dirty="0">
+              <a:solidFill>
+                <a:srgbClr val="FFFFFF"/>
+              </a:solidFill>
+            </a:endParaRPr>
+          </a:p>
+          <a:p>
+            <a:r>
+              <a:rPr lang="en-US" dirty="0">
+                <a:solidFill>
+                  <a:srgbClr val="FFFFFF"/>
+                </a:solidFill>
+              </a:rPr>
+              <a:t>Larger max token limit for BERT embeddings</a:t>
+            </a:r>
+          </a:p>
+        </p:txBody>
+      </p:sp>
+      <p:pic>
+        <p:nvPicPr>
+          <p:cNvPr id="5124" name="Picture 4" descr="Emergency Room App by Santiago Alonso on Dribbble">
+            <a:extLst>
+              <a:ext uri="{FF2B5EF4-FFF2-40B4-BE49-F238E27FC236}">
+                <a16:creationId xmlns:a16="http://schemas.microsoft.com/office/drawing/2014/main" id="{021468C8-407A-9B7E-C306-835FC54BADEB}"/>
+              </a:ext>
+            </a:extLst>
+          </p:cNvPr>
+          <p:cNvPicPr>
+            <a:picLocks noChangeAspect="1" noChangeArrowheads="1"/>
+          </p:cNvPicPr>
+          <p:nvPr/>
+        </p:nvPicPr>
+        <p:blipFill>
+          <a:blip r:embed="rId3">
+            <a:extLst>
+              <a:ext uri="{28A0092B-C50C-407E-A947-70E740481C1C}">
+                <a14:useLocalDpi xmlns:a14="http://schemas.microsoft.com/office/drawing/2010/main" val="0"/>
+              </a:ext>
+            </a:extLst>
+          </a:blip>
+          <a:srcRect l="8073" r="8663"/>
+          <a:stretch/>
+        </p:blipFill>
+        <p:spPr bwMode="auto">
+          <a:xfrm>
+            <a:off x="4578270" y="-11"/>
+            <a:ext cx="7613730" cy="6858000"/>
+          </a:xfrm>
+          <a:prstGeom prst="rect">
+            <a:avLst/>
+          </a:prstGeom>
+          <a:noFill/>
+          <a:extLst>
+            <a:ext uri="{909E8E84-426E-40DD-AFC4-6F175D3DCCD1}">
+              <a14:hiddenFill xmlns:a14="http://schemas.microsoft.com/office/drawing/2010/main">
+                <a:solidFill>
+                  <a:srgbClr val="FFFFFF"/>
+                </a:solidFill>
+              </a14:hiddenFill>
+            </a:ext>
+          </a:extLst>
+        </p:spPr>
+      </p:pic>
+      <p:sp>
+        <p:nvSpPr>
+          <p:cNvPr id="5133" name="Rectangle 5132">
+            <a:extLst>
+              <a:ext uri="{FF2B5EF4-FFF2-40B4-BE49-F238E27FC236}">
+                <a16:creationId xmlns:a16="http://schemas.microsoft.com/office/drawing/2014/main" id="{DD0C6C3A-73B1-4E33-AD0D-8BCD35B714CD}"/>
+              </a:ext>
+              <a:ext uri="{C183D7F6-B498-43B3-948B-1728B52AA6E4}">
+                <adec:decorative xmlns:adec="http://schemas.microsoft.com/office/drawing/2017/decorative" val="1"/>
+              </a:ext>
+            </a:extLst>
+          </p:cNvPr>
+          <p:cNvSpPr>
+            <a:spLocks noGrp="1" noRot="1" noChangeAspect="1" noMove="1" noResize="1" noEditPoints="1" noAdjustHandles="1" noChangeArrowheads="1" noChangeShapeType="1" noTextEdit="1"/>
+          </p:cNvSpPr>
+          <p:nvPr>
+            <p:extLst>
+              <p:ext uri="{386F3935-93C4-4BCD-93E2-E3B085C9AB24}">
+                <p16:designElem xmlns:p16="http://schemas.microsoft.com/office/powerpoint/2015/main" val="1"/>
+              </p:ext>
+            </p:extLst>
+          </p:nvPr>
+        </p:nvSpPr>
+        <p:spPr>
+          <a:xfrm>
+            <a:off x="4530517" y="-460"/>
+            <a:ext cx="91440" cy="6858000"/>
+          </a:xfrm>
+          <a:prstGeom prst="rect">
+            <a:avLst/>
+          </a:prstGeom>
+          <a:solidFill>
+            <a:srgbClr val="FFFFFF"/>
+          </a:solidFill>
+          <a:ln>
+            <a:noFill/>
+          </a:ln>
+          <a:effectLst/>
+        </p:spPr>
+        <p:style>
+          <a:lnRef idx="1">
+            <a:schemeClr val="accent1"/>
+          </a:lnRef>
+          <a:fillRef idx="3">
+            <a:schemeClr val="accent1"/>
+          </a:fillRef>
+          <a:effectRef idx="2">
+            <a:schemeClr val="accent1"/>
+          </a:effectRef>
+          <a:fontRef idx="minor">
+            <a:schemeClr val="lt1"/>
+          </a:fontRef>
+        </p:style>
+        <p:txBody>
+          <a:bodyPr rtlCol="0" anchor="ctr"/>
+          <a:lstStyle/>
+          <a:p>
+            <a:pPr algn="ctr"/>
+            <a:endParaRPr lang="en-US"/>
+          </a:p>
+        </p:txBody>
+      </p:sp>
+      <p:sp>
+        <p:nvSpPr>
+          <p:cNvPr id="5135" name="Rectangle 5134">
+            <a:extLst>
+              <a:ext uri="{FF2B5EF4-FFF2-40B4-BE49-F238E27FC236}">
+                <a16:creationId xmlns:a16="http://schemas.microsoft.com/office/drawing/2014/main" id="{303022F3-BFF5-4104-AE9A-399949DAFC26}"/>
+              </a:ext>
+              <a:ext uri="{C183D7F6-B498-43B3-948B-1728B52AA6E4}">
+                <adec:decorative xmlns:adec="http://schemas.microsoft.com/office/drawing/2017/decorative" val="1"/>
+              </a:ext>
+            </a:extLst>
+          </p:cNvPr>
+          <p:cNvSpPr>
+            <a:spLocks noGrp="1" noRot="1" noChangeAspect="1" noMove="1" noResize="1" noEditPoints="1" noAdjustHandles="1" noChangeArrowheads="1" noChangeShapeType="1" noTextEdit="1"/>
+          </p:cNvSpPr>
+          <p:nvPr>
+            <p:extLst>
+              <p:ext uri="{386F3935-93C4-4BCD-93E2-E3B085C9AB24}">
+                <p16:designElem xmlns:p16="http://schemas.microsoft.com/office/powerpoint/2015/main" val="1"/>
+              </p:ext>
+            </p:extLst>
+          </p:nvPr>
+        </p:nvSpPr>
+        <p:spPr>
+          <a:xfrm>
+            <a:off x="-139" y="2560620"/>
+            <a:ext cx="4581144" cy="91440"/>
+          </a:xfrm>
+          <a:prstGeom prst="rect">
+            <a:avLst/>
+          </a:prstGeom>
+          <a:solidFill>
+            <a:srgbClr val="FFFFFF"/>
+          </a:solidFill>
+          <a:ln>
+            <a:noFill/>
+          </a:ln>
+          <a:effectLst/>
+        </p:spPr>
+        <p:style>
+          <a:lnRef idx="1">
+            <a:schemeClr val="accent1"/>
+          </a:lnRef>
+          <a:fillRef idx="3">
+            <a:schemeClr val="accent1"/>
+          </a:fillRef>
+          <a:effectRef idx="2">
+            <a:schemeClr val="accent1"/>
+          </a:effectRef>
+          <a:fontRef idx="minor">
+            <a:schemeClr val="lt1"/>
+          </a:fontRef>
+        </p:style>
+        <p:txBody>
+          <a:bodyPr/>
+          <a:lstStyle/>
+          <a:p>
+            <a:endParaRPr lang="en-US"/>
+          </a:p>
+        </p:txBody>
+      </p:sp>
+    </p:spTree>
+    <p:extLst>
+      <p:ext uri="{BB962C8B-B14F-4D97-AF65-F5344CB8AC3E}">
+        <p14:creationId xmlns:p14="http://schemas.microsoft.com/office/powerpoint/2010/main" val="959642752"/>
+      </p:ext>
+    </p:extLst>
+  </p:cSld>
+  <p:clrMapOvr>
+    <a:overrideClrMapping bg1="dk1" tx1="lt1" bg2="dk2" tx2="lt2" accent1="accent1" accent2="accent2" accent3="accent3" accent4="accent4" accent5="accent5" accent6="accent6" hlink="hlink" folHlink="folHlink"/>
   </p:clrMapOvr>
 </p:sld>
 </file>

</xml_diff>